<commit_message>
Use Japanese copy in repository videos
</commit_message>
<xml_diff>
--- a/video-assets/repositories/king-epark-neo/king-epark-neo-tech-preview.pptx
+++ b/video-assets/repositories/king-epark-neo/king-epark-neo-tech-preview.pptx
@@ -134,7 +134,7 @@
           <p:cNvPr id="2" name="タイトル 1">
             <a:extLst>
               <a:ext uri="{FF2B5EF4-FFF2-40B4-BE49-F238E27FC236}">
-                <a16:creationId xmlns:a16="http://schemas.microsoft.com/office/drawing/2014/main" id="{F8BF381E-D06D-E33E-B126-2E6CAADF8B1F}"/>
+                <a16:creationId xmlns:a16="http://schemas.microsoft.com/office/drawing/2014/main" id="{8BDBA2E4-31C0-7E28-2662-A20C0BCA83EC}"/>
               </a:ext>
             </a:extLst>
           </p:cNvPr>
@@ -171,7 +171,7 @@
           <p:cNvPr id="3" name="字幕 2">
             <a:extLst>
               <a:ext uri="{FF2B5EF4-FFF2-40B4-BE49-F238E27FC236}">
-                <a16:creationId xmlns:a16="http://schemas.microsoft.com/office/drawing/2014/main" id="{7AAC9B04-65B4-0EBE-D479-D34F03DF6805}"/>
+                <a16:creationId xmlns:a16="http://schemas.microsoft.com/office/drawing/2014/main" id="{338A680B-065F-1B07-0A42-EBF4E401C4B3}"/>
               </a:ext>
             </a:extLst>
           </p:cNvPr>
@@ -241,7 +241,7 @@
           <p:cNvPr id="4" name="日付プレースホルダー 3">
             <a:extLst>
               <a:ext uri="{FF2B5EF4-FFF2-40B4-BE49-F238E27FC236}">
-                <a16:creationId xmlns:a16="http://schemas.microsoft.com/office/drawing/2014/main" id="{3D63392C-23C9-BDBA-B832-CFD30F38C2CC}"/>
+                <a16:creationId xmlns:a16="http://schemas.microsoft.com/office/drawing/2014/main" id="{0CE4BE0D-734B-8882-BDCB-449212345804}"/>
               </a:ext>
             </a:extLst>
           </p:cNvPr>
@@ -257,7 +257,7 @@
           <a:bodyPr/>
           <a:lstStyle/>
           <a:p>
-            <a:fld id="{46C14D9D-2B16-4C56-91DD-5F9D5BDEC962}" type="datetimeFigureOut">
+            <a:fld id="{4ABB2253-A87D-461A-BEF5-E9762CC1454B}" type="datetimeFigureOut">
               <a:rPr kumimoji="1" lang="ja-JP" altLang="en-US" smtClean="0"/>
               <a:t>2026/8/2</a:t>
             </a:fld>
@@ -270,7 +270,7 @@
           <p:cNvPr id="5" name="フッター プレースホルダー 4">
             <a:extLst>
               <a:ext uri="{FF2B5EF4-FFF2-40B4-BE49-F238E27FC236}">
-                <a16:creationId xmlns:a16="http://schemas.microsoft.com/office/drawing/2014/main" id="{D70F6269-7382-54CC-2CD7-CDA62F0B1B3B}"/>
+                <a16:creationId xmlns:a16="http://schemas.microsoft.com/office/drawing/2014/main" id="{9E89F922-0E28-B924-2430-B148C9B5EAA9}"/>
               </a:ext>
             </a:extLst>
           </p:cNvPr>
@@ -295,7 +295,7 @@
           <p:cNvPr id="6" name="スライド番号プレースホルダー 5">
             <a:extLst>
               <a:ext uri="{FF2B5EF4-FFF2-40B4-BE49-F238E27FC236}">
-                <a16:creationId xmlns:a16="http://schemas.microsoft.com/office/drawing/2014/main" id="{C0D31134-3FC0-DB6C-3D05-7EFBC83D1A4A}"/>
+                <a16:creationId xmlns:a16="http://schemas.microsoft.com/office/drawing/2014/main" id="{F711F73D-AFC6-3AD4-E490-48AE6C56A6D8}"/>
               </a:ext>
             </a:extLst>
           </p:cNvPr>
@@ -311,7 +311,7 @@
           <a:bodyPr/>
           <a:lstStyle/>
           <a:p>
-            <a:fld id="{20DA1BB6-7E1D-47A7-8B10-5332310EF6B2}" type="slidenum">
+            <a:fld id="{D559EA92-F8DF-420E-A5E8-4940031E9E8E}" type="slidenum">
               <a:rPr kumimoji="1" lang="ja-JP" altLang="en-US" smtClean="0"/>
               <a:t>‹#›</a:t>
             </a:fld>
@@ -322,7 +322,7 @@
     </p:spTree>
     <p:extLst>
       <p:ext uri="{BB962C8B-B14F-4D97-AF65-F5344CB8AC3E}">
-        <p14:creationId xmlns:p14="http://schemas.microsoft.com/office/powerpoint/2010/main" val="1340799366"/>
+        <p14:creationId xmlns:p14="http://schemas.microsoft.com/office/powerpoint/2010/main" val="729007969"/>
       </p:ext>
     </p:extLst>
   </p:cSld>
@@ -354,7 +354,7 @@
           <p:cNvPr id="2" name="タイトル 1">
             <a:extLst>
               <a:ext uri="{FF2B5EF4-FFF2-40B4-BE49-F238E27FC236}">
-                <a16:creationId xmlns:a16="http://schemas.microsoft.com/office/drawing/2014/main" id="{A6994529-94B0-D67E-D76D-C9AC99DD6670}"/>
+                <a16:creationId xmlns:a16="http://schemas.microsoft.com/office/drawing/2014/main" id="{5FBC8B20-A406-29CE-1389-CE38A03D10F0}"/>
               </a:ext>
             </a:extLst>
           </p:cNvPr>
@@ -382,7 +382,7 @@
           <p:cNvPr id="3" name="縦書きテキスト プレースホルダー 2">
             <a:extLst>
               <a:ext uri="{FF2B5EF4-FFF2-40B4-BE49-F238E27FC236}">
-                <a16:creationId xmlns:a16="http://schemas.microsoft.com/office/drawing/2014/main" id="{3F2E4AF5-81B9-7D69-2450-92BB86D9001D}"/>
+                <a16:creationId xmlns:a16="http://schemas.microsoft.com/office/drawing/2014/main" id="{E115DECE-EADC-665A-A4A0-BBB2C4BC28DE}"/>
               </a:ext>
             </a:extLst>
           </p:cNvPr>
@@ -471,7 +471,7 @@
           <p:cNvPr id="4" name="日付プレースホルダー 3">
             <a:extLst>
               <a:ext uri="{FF2B5EF4-FFF2-40B4-BE49-F238E27FC236}">
-                <a16:creationId xmlns:a16="http://schemas.microsoft.com/office/drawing/2014/main" id="{B10CDD9F-B064-059D-41F0-83D7DE12D7BF}"/>
+                <a16:creationId xmlns:a16="http://schemas.microsoft.com/office/drawing/2014/main" id="{113A0E91-0C99-6ABD-B0DA-46B479695813}"/>
               </a:ext>
             </a:extLst>
           </p:cNvPr>
@@ -487,7 +487,7 @@
           <a:bodyPr/>
           <a:lstStyle/>
           <a:p>
-            <a:fld id="{46C14D9D-2B16-4C56-91DD-5F9D5BDEC962}" type="datetimeFigureOut">
+            <a:fld id="{4ABB2253-A87D-461A-BEF5-E9762CC1454B}" type="datetimeFigureOut">
               <a:rPr kumimoji="1" lang="ja-JP" altLang="en-US" smtClean="0"/>
               <a:t>2026/8/2</a:t>
             </a:fld>
@@ -500,7 +500,7 @@
           <p:cNvPr id="5" name="フッター プレースホルダー 4">
             <a:extLst>
               <a:ext uri="{FF2B5EF4-FFF2-40B4-BE49-F238E27FC236}">
-                <a16:creationId xmlns:a16="http://schemas.microsoft.com/office/drawing/2014/main" id="{1B596929-A0EE-DAEE-BC7F-86EA01DEEEF2}"/>
+                <a16:creationId xmlns:a16="http://schemas.microsoft.com/office/drawing/2014/main" id="{9E9E8317-422D-FBD6-9EE7-3ED570A498F6}"/>
               </a:ext>
             </a:extLst>
           </p:cNvPr>
@@ -525,7 +525,7 @@
           <p:cNvPr id="6" name="スライド番号プレースホルダー 5">
             <a:extLst>
               <a:ext uri="{FF2B5EF4-FFF2-40B4-BE49-F238E27FC236}">
-                <a16:creationId xmlns:a16="http://schemas.microsoft.com/office/drawing/2014/main" id="{6EFD7878-48AD-4AA4-3A83-E0AE4DE82225}"/>
+                <a16:creationId xmlns:a16="http://schemas.microsoft.com/office/drawing/2014/main" id="{9709887D-8C8B-F370-0BB6-470C5D45EE64}"/>
               </a:ext>
             </a:extLst>
           </p:cNvPr>
@@ -541,7 +541,7 @@
           <a:bodyPr/>
           <a:lstStyle/>
           <a:p>
-            <a:fld id="{20DA1BB6-7E1D-47A7-8B10-5332310EF6B2}" type="slidenum">
+            <a:fld id="{D559EA92-F8DF-420E-A5E8-4940031E9E8E}" type="slidenum">
               <a:rPr kumimoji="1" lang="ja-JP" altLang="en-US" smtClean="0"/>
               <a:t>‹#›</a:t>
             </a:fld>
@@ -552,7 +552,7 @@
     </p:spTree>
     <p:extLst>
       <p:ext uri="{BB962C8B-B14F-4D97-AF65-F5344CB8AC3E}">
-        <p14:creationId xmlns:p14="http://schemas.microsoft.com/office/powerpoint/2010/main" val="3601484877"/>
+        <p14:creationId xmlns:p14="http://schemas.microsoft.com/office/powerpoint/2010/main" val="576623341"/>
       </p:ext>
     </p:extLst>
   </p:cSld>
@@ -584,7 +584,7 @@
           <p:cNvPr id="2" name="縦書きタイトル 1">
             <a:extLst>
               <a:ext uri="{FF2B5EF4-FFF2-40B4-BE49-F238E27FC236}">
-                <a16:creationId xmlns:a16="http://schemas.microsoft.com/office/drawing/2014/main" id="{38A7DF47-5665-0869-3209-AF4FEF079AD8}"/>
+                <a16:creationId xmlns:a16="http://schemas.microsoft.com/office/drawing/2014/main" id="{831A892A-9C8B-48D0-FC4C-E72AFCCF55D5}"/>
               </a:ext>
             </a:extLst>
           </p:cNvPr>
@@ -617,7 +617,7 @@
           <p:cNvPr id="3" name="縦書きテキスト プレースホルダー 2">
             <a:extLst>
               <a:ext uri="{FF2B5EF4-FFF2-40B4-BE49-F238E27FC236}">
-                <a16:creationId xmlns:a16="http://schemas.microsoft.com/office/drawing/2014/main" id="{291F68E7-4F0F-4676-5CD3-5A924291931A}"/>
+                <a16:creationId xmlns:a16="http://schemas.microsoft.com/office/drawing/2014/main" id="{0E350507-C213-224C-F9BA-4A596905F9B1}"/>
               </a:ext>
             </a:extLst>
           </p:cNvPr>
@@ -711,7 +711,7 @@
           <p:cNvPr id="4" name="日付プレースホルダー 3">
             <a:extLst>
               <a:ext uri="{FF2B5EF4-FFF2-40B4-BE49-F238E27FC236}">
-                <a16:creationId xmlns:a16="http://schemas.microsoft.com/office/drawing/2014/main" id="{1EA8E144-835B-75D2-2A2C-32175F2F282F}"/>
+                <a16:creationId xmlns:a16="http://schemas.microsoft.com/office/drawing/2014/main" id="{15908E8A-73AC-786C-6057-5D26BC1D26EC}"/>
               </a:ext>
             </a:extLst>
           </p:cNvPr>
@@ -727,7 +727,7 @@
           <a:bodyPr/>
           <a:lstStyle/>
           <a:p>
-            <a:fld id="{46C14D9D-2B16-4C56-91DD-5F9D5BDEC962}" type="datetimeFigureOut">
+            <a:fld id="{4ABB2253-A87D-461A-BEF5-E9762CC1454B}" type="datetimeFigureOut">
               <a:rPr kumimoji="1" lang="ja-JP" altLang="en-US" smtClean="0"/>
               <a:t>2026/8/2</a:t>
             </a:fld>
@@ -740,7 +740,7 @@
           <p:cNvPr id="5" name="フッター プレースホルダー 4">
             <a:extLst>
               <a:ext uri="{FF2B5EF4-FFF2-40B4-BE49-F238E27FC236}">
-                <a16:creationId xmlns:a16="http://schemas.microsoft.com/office/drawing/2014/main" id="{8FCB7B51-4D85-86AA-7DCC-71819C0FDF36}"/>
+                <a16:creationId xmlns:a16="http://schemas.microsoft.com/office/drawing/2014/main" id="{70B63605-D256-EE45-79A7-0F11E86820D8}"/>
               </a:ext>
             </a:extLst>
           </p:cNvPr>
@@ -765,7 +765,7 @@
           <p:cNvPr id="6" name="スライド番号プレースホルダー 5">
             <a:extLst>
               <a:ext uri="{FF2B5EF4-FFF2-40B4-BE49-F238E27FC236}">
-                <a16:creationId xmlns:a16="http://schemas.microsoft.com/office/drawing/2014/main" id="{7C3C66F5-45F6-CFD4-E5F1-25D8211FC4A5}"/>
+                <a16:creationId xmlns:a16="http://schemas.microsoft.com/office/drawing/2014/main" id="{E9D79D58-01A5-DDE1-5163-E5AF01EE7B58}"/>
               </a:ext>
             </a:extLst>
           </p:cNvPr>
@@ -781,7 +781,7 @@
           <a:bodyPr/>
           <a:lstStyle/>
           <a:p>
-            <a:fld id="{20DA1BB6-7E1D-47A7-8B10-5332310EF6B2}" type="slidenum">
+            <a:fld id="{D559EA92-F8DF-420E-A5E8-4940031E9E8E}" type="slidenum">
               <a:rPr kumimoji="1" lang="ja-JP" altLang="en-US" smtClean="0"/>
               <a:t>‹#›</a:t>
             </a:fld>
@@ -792,7 +792,7 @@
     </p:spTree>
     <p:extLst>
       <p:ext uri="{BB962C8B-B14F-4D97-AF65-F5344CB8AC3E}">
-        <p14:creationId xmlns:p14="http://schemas.microsoft.com/office/powerpoint/2010/main" val="705891364"/>
+        <p14:creationId xmlns:p14="http://schemas.microsoft.com/office/powerpoint/2010/main" val="2036133662"/>
       </p:ext>
     </p:extLst>
   </p:cSld>
@@ -824,7 +824,7 @@
           <p:cNvPr id="2" name="タイトル 1">
             <a:extLst>
               <a:ext uri="{FF2B5EF4-FFF2-40B4-BE49-F238E27FC236}">
-                <a16:creationId xmlns:a16="http://schemas.microsoft.com/office/drawing/2014/main" id="{C5322015-92F7-EC03-FD85-B5B9AEDA0C1A}"/>
+                <a16:creationId xmlns:a16="http://schemas.microsoft.com/office/drawing/2014/main" id="{FE9C163A-6D5E-E263-7F37-3E39E216C722}"/>
               </a:ext>
             </a:extLst>
           </p:cNvPr>
@@ -852,7 +852,7 @@
           <p:cNvPr id="3" name="コンテンツ プレースホルダー 2">
             <a:extLst>
               <a:ext uri="{FF2B5EF4-FFF2-40B4-BE49-F238E27FC236}">
-                <a16:creationId xmlns:a16="http://schemas.microsoft.com/office/drawing/2014/main" id="{036FA61D-7179-A968-AB48-1606250F1C47}"/>
+                <a16:creationId xmlns:a16="http://schemas.microsoft.com/office/drawing/2014/main" id="{C4955FDF-AFD2-935B-D2D0-DB598907412F}"/>
               </a:ext>
             </a:extLst>
           </p:cNvPr>
@@ -941,7 +941,7 @@
           <p:cNvPr id="4" name="日付プレースホルダー 3">
             <a:extLst>
               <a:ext uri="{FF2B5EF4-FFF2-40B4-BE49-F238E27FC236}">
-                <a16:creationId xmlns:a16="http://schemas.microsoft.com/office/drawing/2014/main" id="{CC9BFB05-8FD1-1E94-934A-0BF6452B5BCF}"/>
+                <a16:creationId xmlns:a16="http://schemas.microsoft.com/office/drawing/2014/main" id="{A75548F1-D34B-9709-8B54-E2E7A840014C}"/>
               </a:ext>
             </a:extLst>
           </p:cNvPr>
@@ -957,7 +957,7 @@
           <a:bodyPr/>
           <a:lstStyle/>
           <a:p>
-            <a:fld id="{46C14D9D-2B16-4C56-91DD-5F9D5BDEC962}" type="datetimeFigureOut">
+            <a:fld id="{4ABB2253-A87D-461A-BEF5-E9762CC1454B}" type="datetimeFigureOut">
               <a:rPr kumimoji="1" lang="ja-JP" altLang="en-US" smtClean="0"/>
               <a:t>2026/8/2</a:t>
             </a:fld>
@@ -970,7 +970,7 @@
           <p:cNvPr id="5" name="フッター プレースホルダー 4">
             <a:extLst>
               <a:ext uri="{FF2B5EF4-FFF2-40B4-BE49-F238E27FC236}">
-                <a16:creationId xmlns:a16="http://schemas.microsoft.com/office/drawing/2014/main" id="{47E37CF5-99B3-AA08-F6E5-519BD6D97BD7}"/>
+                <a16:creationId xmlns:a16="http://schemas.microsoft.com/office/drawing/2014/main" id="{B1DE4E9A-DF0C-8E1F-D942-F8806DDE5530}"/>
               </a:ext>
             </a:extLst>
           </p:cNvPr>
@@ -995,7 +995,7 @@
           <p:cNvPr id="6" name="スライド番号プレースホルダー 5">
             <a:extLst>
               <a:ext uri="{FF2B5EF4-FFF2-40B4-BE49-F238E27FC236}">
-                <a16:creationId xmlns:a16="http://schemas.microsoft.com/office/drawing/2014/main" id="{40CDF67B-F11C-C5E6-AA51-065514D77718}"/>
+                <a16:creationId xmlns:a16="http://schemas.microsoft.com/office/drawing/2014/main" id="{0C49EB10-0EAB-FB5C-169B-28C20EBD4537}"/>
               </a:ext>
             </a:extLst>
           </p:cNvPr>
@@ -1011,7 +1011,7 @@
           <a:bodyPr/>
           <a:lstStyle/>
           <a:p>
-            <a:fld id="{20DA1BB6-7E1D-47A7-8B10-5332310EF6B2}" type="slidenum">
+            <a:fld id="{D559EA92-F8DF-420E-A5E8-4940031E9E8E}" type="slidenum">
               <a:rPr kumimoji="1" lang="ja-JP" altLang="en-US" smtClean="0"/>
               <a:t>‹#›</a:t>
             </a:fld>
@@ -1022,7 +1022,7 @@
     </p:spTree>
     <p:extLst>
       <p:ext uri="{BB962C8B-B14F-4D97-AF65-F5344CB8AC3E}">
-        <p14:creationId xmlns:p14="http://schemas.microsoft.com/office/powerpoint/2010/main" val="2410650991"/>
+        <p14:creationId xmlns:p14="http://schemas.microsoft.com/office/powerpoint/2010/main" val="2011285049"/>
       </p:ext>
     </p:extLst>
   </p:cSld>
@@ -1054,7 +1054,7 @@
           <p:cNvPr id="2" name="タイトル 1">
             <a:extLst>
               <a:ext uri="{FF2B5EF4-FFF2-40B4-BE49-F238E27FC236}">
-                <a16:creationId xmlns:a16="http://schemas.microsoft.com/office/drawing/2014/main" id="{275329F2-B706-7286-84B0-E9E9AF4F0B4F}"/>
+                <a16:creationId xmlns:a16="http://schemas.microsoft.com/office/drawing/2014/main" id="{BA880D02-0B09-85D7-3434-66BB25CD049C}"/>
               </a:ext>
             </a:extLst>
           </p:cNvPr>
@@ -1091,7 +1091,7 @@
           <p:cNvPr id="3" name="テキスト プレースホルダー 2">
             <a:extLst>
               <a:ext uri="{FF2B5EF4-FFF2-40B4-BE49-F238E27FC236}">
-                <a16:creationId xmlns:a16="http://schemas.microsoft.com/office/drawing/2014/main" id="{B1A1A90C-6997-0FC7-65D1-C045276F78B4}"/>
+                <a16:creationId xmlns:a16="http://schemas.microsoft.com/office/drawing/2014/main" id="{BB7DDA32-16E0-042F-1BB5-35CECEB765CF}"/>
               </a:ext>
             </a:extLst>
           </p:cNvPr>
@@ -1216,7 +1216,7 @@
           <p:cNvPr id="4" name="日付プレースホルダー 3">
             <a:extLst>
               <a:ext uri="{FF2B5EF4-FFF2-40B4-BE49-F238E27FC236}">
-                <a16:creationId xmlns:a16="http://schemas.microsoft.com/office/drawing/2014/main" id="{D4CBF3C1-DB5A-4955-4CFA-3BA18998EFEC}"/>
+                <a16:creationId xmlns:a16="http://schemas.microsoft.com/office/drawing/2014/main" id="{42C20A3E-BBDD-BC20-EB01-8DE1AE92427D}"/>
               </a:ext>
             </a:extLst>
           </p:cNvPr>
@@ -1232,7 +1232,7 @@
           <a:bodyPr/>
           <a:lstStyle/>
           <a:p>
-            <a:fld id="{46C14D9D-2B16-4C56-91DD-5F9D5BDEC962}" type="datetimeFigureOut">
+            <a:fld id="{4ABB2253-A87D-461A-BEF5-E9762CC1454B}" type="datetimeFigureOut">
               <a:rPr kumimoji="1" lang="ja-JP" altLang="en-US" smtClean="0"/>
               <a:t>2026/8/2</a:t>
             </a:fld>
@@ -1245,7 +1245,7 @@
           <p:cNvPr id="5" name="フッター プレースホルダー 4">
             <a:extLst>
               <a:ext uri="{FF2B5EF4-FFF2-40B4-BE49-F238E27FC236}">
-                <a16:creationId xmlns:a16="http://schemas.microsoft.com/office/drawing/2014/main" id="{9AFA12B3-682B-6374-30EE-E86977CC8D83}"/>
+                <a16:creationId xmlns:a16="http://schemas.microsoft.com/office/drawing/2014/main" id="{3D9E35A1-8626-BF25-34A3-50B63C0FC038}"/>
               </a:ext>
             </a:extLst>
           </p:cNvPr>
@@ -1270,7 +1270,7 @@
           <p:cNvPr id="6" name="スライド番号プレースホルダー 5">
             <a:extLst>
               <a:ext uri="{FF2B5EF4-FFF2-40B4-BE49-F238E27FC236}">
-                <a16:creationId xmlns:a16="http://schemas.microsoft.com/office/drawing/2014/main" id="{D3DED666-CA41-8877-9555-A57228830BBB}"/>
+                <a16:creationId xmlns:a16="http://schemas.microsoft.com/office/drawing/2014/main" id="{5C919555-9243-A860-3FA0-B78FE1C30739}"/>
               </a:ext>
             </a:extLst>
           </p:cNvPr>
@@ -1286,7 +1286,7 @@
           <a:bodyPr/>
           <a:lstStyle/>
           <a:p>
-            <a:fld id="{20DA1BB6-7E1D-47A7-8B10-5332310EF6B2}" type="slidenum">
+            <a:fld id="{D559EA92-F8DF-420E-A5E8-4940031E9E8E}" type="slidenum">
               <a:rPr kumimoji="1" lang="ja-JP" altLang="en-US" smtClean="0"/>
               <a:t>‹#›</a:t>
             </a:fld>
@@ -1297,7 +1297,7 @@
     </p:spTree>
     <p:extLst>
       <p:ext uri="{BB962C8B-B14F-4D97-AF65-F5344CB8AC3E}">
-        <p14:creationId xmlns:p14="http://schemas.microsoft.com/office/powerpoint/2010/main" val="3573507501"/>
+        <p14:creationId xmlns:p14="http://schemas.microsoft.com/office/powerpoint/2010/main" val="4210148107"/>
       </p:ext>
     </p:extLst>
   </p:cSld>
@@ -1329,7 +1329,7 @@
           <p:cNvPr id="2" name="タイトル 1">
             <a:extLst>
               <a:ext uri="{FF2B5EF4-FFF2-40B4-BE49-F238E27FC236}">
-                <a16:creationId xmlns:a16="http://schemas.microsoft.com/office/drawing/2014/main" id="{237D1F3F-03A8-C060-ECB8-52160E298583}"/>
+                <a16:creationId xmlns:a16="http://schemas.microsoft.com/office/drawing/2014/main" id="{9288F5E5-496E-D8EE-5966-9B1B6D1DAFBD}"/>
               </a:ext>
             </a:extLst>
           </p:cNvPr>
@@ -1357,7 +1357,7 @@
           <p:cNvPr id="3" name="コンテンツ プレースホルダー 2">
             <a:extLst>
               <a:ext uri="{FF2B5EF4-FFF2-40B4-BE49-F238E27FC236}">
-                <a16:creationId xmlns:a16="http://schemas.microsoft.com/office/drawing/2014/main" id="{D4FA305D-5AD9-040B-8CF7-69D17D39C5E3}"/>
+                <a16:creationId xmlns:a16="http://schemas.microsoft.com/office/drawing/2014/main" id="{51B5281D-F7D7-7D6E-2A93-EBCC09D3ADCD}"/>
               </a:ext>
             </a:extLst>
           </p:cNvPr>
@@ -1451,7 +1451,7 @@
           <p:cNvPr id="4" name="コンテンツ プレースホルダー 3">
             <a:extLst>
               <a:ext uri="{FF2B5EF4-FFF2-40B4-BE49-F238E27FC236}">
-                <a16:creationId xmlns:a16="http://schemas.microsoft.com/office/drawing/2014/main" id="{8F31B099-DACE-350D-A4D9-4E7E164BF72E}"/>
+                <a16:creationId xmlns:a16="http://schemas.microsoft.com/office/drawing/2014/main" id="{E9C5CD86-3E46-DDF3-C844-07D3B090C928}"/>
               </a:ext>
             </a:extLst>
           </p:cNvPr>
@@ -1545,7 +1545,7 @@
           <p:cNvPr id="5" name="日付プレースホルダー 4">
             <a:extLst>
               <a:ext uri="{FF2B5EF4-FFF2-40B4-BE49-F238E27FC236}">
-                <a16:creationId xmlns:a16="http://schemas.microsoft.com/office/drawing/2014/main" id="{D6961CA6-D9AA-A7D5-06F6-C54B57D83CBF}"/>
+                <a16:creationId xmlns:a16="http://schemas.microsoft.com/office/drawing/2014/main" id="{6AD812C7-B539-F812-63FA-41E31B5A14B5}"/>
               </a:ext>
             </a:extLst>
           </p:cNvPr>
@@ -1561,7 +1561,7 @@
           <a:bodyPr/>
           <a:lstStyle/>
           <a:p>
-            <a:fld id="{46C14D9D-2B16-4C56-91DD-5F9D5BDEC962}" type="datetimeFigureOut">
+            <a:fld id="{4ABB2253-A87D-461A-BEF5-E9762CC1454B}" type="datetimeFigureOut">
               <a:rPr kumimoji="1" lang="ja-JP" altLang="en-US" smtClean="0"/>
               <a:t>2026/8/2</a:t>
             </a:fld>
@@ -1574,7 +1574,7 @@
           <p:cNvPr id="6" name="フッター プレースホルダー 5">
             <a:extLst>
               <a:ext uri="{FF2B5EF4-FFF2-40B4-BE49-F238E27FC236}">
-                <a16:creationId xmlns:a16="http://schemas.microsoft.com/office/drawing/2014/main" id="{FCC36626-0446-12E4-814A-F5EA186D4FF2}"/>
+                <a16:creationId xmlns:a16="http://schemas.microsoft.com/office/drawing/2014/main" id="{A8775ABD-CDB6-0868-D03C-CD6D848FE543}"/>
               </a:ext>
             </a:extLst>
           </p:cNvPr>
@@ -1599,7 +1599,7 @@
           <p:cNvPr id="7" name="スライド番号プレースホルダー 6">
             <a:extLst>
               <a:ext uri="{FF2B5EF4-FFF2-40B4-BE49-F238E27FC236}">
-                <a16:creationId xmlns:a16="http://schemas.microsoft.com/office/drawing/2014/main" id="{234AAC55-D5F2-E655-55F1-25058A8D43E3}"/>
+                <a16:creationId xmlns:a16="http://schemas.microsoft.com/office/drawing/2014/main" id="{E08ECB5B-F058-9D24-6C76-10021B963B61}"/>
               </a:ext>
             </a:extLst>
           </p:cNvPr>
@@ -1615,7 +1615,7 @@
           <a:bodyPr/>
           <a:lstStyle/>
           <a:p>
-            <a:fld id="{20DA1BB6-7E1D-47A7-8B10-5332310EF6B2}" type="slidenum">
+            <a:fld id="{D559EA92-F8DF-420E-A5E8-4940031E9E8E}" type="slidenum">
               <a:rPr kumimoji="1" lang="ja-JP" altLang="en-US" smtClean="0"/>
               <a:t>‹#›</a:t>
             </a:fld>
@@ -1626,7 +1626,7 @@
     </p:spTree>
     <p:extLst>
       <p:ext uri="{BB962C8B-B14F-4D97-AF65-F5344CB8AC3E}">
-        <p14:creationId xmlns:p14="http://schemas.microsoft.com/office/powerpoint/2010/main" val="2761856363"/>
+        <p14:creationId xmlns:p14="http://schemas.microsoft.com/office/powerpoint/2010/main" val="2631125886"/>
       </p:ext>
     </p:extLst>
   </p:cSld>
@@ -1658,7 +1658,7 @@
           <p:cNvPr id="2" name="タイトル 1">
             <a:extLst>
               <a:ext uri="{FF2B5EF4-FFF2-40B4-BE49-F238E27FC236}">
-                <a16:creationId xmlns:a16="http://schemas.microsoft.com/office/drawing/2014/main" id="{44946AA6-2392-3155-658D-37F2C9A13D1A}"/>
+                <a16:creationId xmlns:a16="http://schemas.microsoft.com/office/drawing/2014/main" id="{90675ED3-9248-FA9E-71A0-81590E1C6745}"/>
               </a:ext>
             </a:extLst>
           </p:cNvPr>
@@ -1691,7 +1691,7 @@
           <p:cNvPr id="3" name="テキスト プレースホルダー 2">
             <a:extLst>
               <a:ext uri="{FF2B5EF4-FFF2-40B4-BE49-F238E27FC236}">
-                <a16:creationId xmlns:a16="http://schemas.microsoft.com/office/drawing/2014/main" id="{E3B53F8A-98B7-C073-8F64-F485522E3846}"/>
+                <a16:creationId xmlns:a16="http://schemas.microsoft.com/office/drawing/2014/main" id="{00A08534-4260-5502-BA2D-27FF662E3887}"/>
               </a:ext>
             </a:extLst>
           </p:cNvPr>
@@ -1762,7 +1762,7 @@
           <p:cNvPr id="4" name="コンテンツ プレースホルダー 3">
             <a:extLst>
               <a:ext uri="{FF2B5EF4-FFF2-40B4-BE49-F238E27FC236}">
-                <a16:creationId xmlns:a16="http://schemas.microsoft.com/office/drawing/2014/main" id="{04A11F80-D1E2-9B48-5935-8F24B83B5DF1}"/>
+                <a16:creationId xmlns:a16="http://schemas.microsoft.com/office/drawing/2014/main" id="{E9EDE405-3729-F328-6C06-2F35DABEAEF4}"/>
               </a:ext>
             </a:extLst>
           </p:cNvPr>
@@ -1856,7 +1856,7 @@
           <p:cNvPr id="5" name="テキスト プレースホルダー 4">
             <a:extLst>
               <a:ext uri="{FF2B5EF4-FFF2-40B4-BE49-F238E27FC236}">
-                <a16:creationId xmlns:a16="http://schemas.microsoft.com/office/drawing/2014/main" id="{D452502D-0D51-6A63-AB39-F0D023454B19}"/>
+                <a16:creationId xmlns:a16="http://schemas.microsoft.com/office/drawing/2014/main" id="{0225D2C6-7945-BD2D-02D5-7C1AA55A091F}"/>
               </a:ext>
             </a:extLst>
           </p:cNvPr>
@@ -1927,7 +1927,7 @@
           <p:cNvPr id="6" name="コンテンツ プレースホルダー 5">
             <a:extLst>
               <a:ext uri="{FF2B5EF4-FFF2-40B4-BE49-F238E27FC236}">
-                <a16:creationId xmlns:a16="http://schemas.microsoft.com/office/drawing/2014/main" id="{F29E1276-715C-E5E0-FF58-ECAF669EC0C4}"/>
+                <a16:creationId xmlns:a16="http://schemas.microsoft.com/office/drawing/2014/main" id="{0A3E2417-E543-5F3D-C3AF-14D58F5AF4E3}"/>
               </a:ext>
             </a:extLst>
           </p:cNvPr>
@@ -2021,7 +2021,7 @@
           <p:cNvPr id="7" name="日付プレースホルダー 6">
             <a:extLst>
               <a:ext uri="{FF2B5EF4-FFF2-40B4-BE49-F238E27FC236}">
-                <a16:creationId xmlns:a16="http://schemas.microsoft.com/office/drawing/2014/main" id="{306E38DC-5F4D-EFF6-6065-B747F0BE61A3}"/>
+                <a16:creationId xmlns:a16="http://schemas.microsoft.com/office/drawing/2014/main" id="{01B70CB7-ADCF-ED20-127A-9162C978E181}"/>
               </a:ext>
             </a:extLst>
           </p:cNvPr>
@@ -2037,7 +2037,7 @@
           <a:bodyPr/>
           <a:lstStyle/>
           <a:p>
-            <a:fld id="{46C14D9D-2B16-4C56-91DD-5F9D5BDEC962}" type="datetimeFigureOut">
+            <a:fld id="{4ABB2253-A87D-461A-BEF5-E9762CC1454B}" type="datetimeFigureOut">
               <a:rPr kumimoji="1" lang="ja-JP" altLang="en-US" smtClean="0"/>
               <a:t>2026/8/2</a:t>
             </a:fld>
@@ -2050,7 +2050,7 @@
           <p:cNvPr id="8" name="フッター プレースホルダー 7">
             <a:extLst>
               <a:ext uri="{FF2B5EF4-FFF2-40B4-BE49-F238E27FC236}">
-                <a16:creationId xmlns:a16="http://schemas.microsoft.com/office/drawing/2014/main" id="{78DB9C46-7463-D3F9-C463-BBF4C0862E87}"/>
+                <a16:creationId xmlns:a16="http://schemas.microsoft.com/office/drawing/2014/main" id="{C53C9E8B-FAA7-7655-A4CD-9DEB9E132D72}"/>
               </a:ext>
             </a:extLst>
           </p:cNvPr>
@@ -2075,7 +2075,7 @@
           <p:cNvPr id="9" name="スライド番号プレースホルダー 8">
             <a:extLst>
               <a:ext uri="{FF2B5EF4-FFF2-40B4-BE49-F238E27FC236}">
-                <a16:creationId xmlns:a16="http://schemas.microsoft.com/office/drawing/2014/main" id="{969A4140-EC70-2A33-0387-568042ACA6C8}"/>
+                <a16:creationId xmlns:a16="http://schemas.microsoft.com/office/drawing/2014/main" id="{53622F84-EC92-AE81-BB00-67054CE0BFFB}"/>
               </a:ext>
             </a:extLst>
           </p:cNvPr>
@@ -2091,7 +2091,7 @@
           <a:bodyPr/>
           <a:lstStyle/>
           <a:p>
-            <a:fld id="{20DA1BB6-7E1D-47A7-8B10-5332310EF6B2}" type="slidenum">
+            <a:fld id="{D559EA92-F8DF-420E-A5E8-4940031E9E8E}" type="slidenum">
               <a:rPr kumimoji="1" lang="ja-JP" altLang="en-US" smtClean="0"/>
               <a:t>‹#›</a:t>
             </a:fld>
@@ -2102,7 +2102,7 @@
     </p:spTree>
     <p:extLst>
       <p:ext uri="{BB962C8B-B14F-4D97-AF65-F5344CB8AC3E}">
-        <p14:creationId xmlns:p14="http://schemas.microsoft.com/office/powerpoint/2010/main" val="1316265838"/>
+        <p14:creationId xmlns:p14="http://schemas.microsoft.com/office/powerpoint/2010/main" val="3768279822"/>
       </p:ext>
     </p:extLst>
   </p:cSld>
@@ -2134,7 +2134,7 @@
           <p:cNvPr id="2" name="タイトル 1">
             <a:extLst>
               <a:ext uri="{FF2B5EF4-FFF2-40B4-BE49-F238E27FC236}">
-                <a16:creationId xmlns:a16="http://schemas.microsoft.com/office/drawing/2014/main" id="{DD9A7244-6977-FCE2-E280-CFA06B31A4B9}"/>
+                <a16:creationId xmlns:a16="http://schemas.microsoft.com/office/drawing/2014/main" id="{EDDB8368-1783-6F2D-87AE-BF69DBE33908}"/>
               </a:ext>
             </a:extLst>
           </p:cNvPr>
@@ -2162,7 +2162,7 @@
           <p:cNvPr id="3" name="日付プレースホルダー 2">
             <a:extLst>
               <a:ext uri="{FF2B5EF4-FFF2-40B4-BE49-F238E27FC236}">
-                <a16:creationId xmlns:a16="http://schemas.microsoft.com/office/drawing/2014/main" id="{5F8D1E7D-8BA9-65C1-393A-1069709F4C18}"/>
+                <a16:creationId xmlns:a16="http://schemas.microsoft.com/office/drawing/2014/main" id="{9A8CECDE-E6C6-38B5-2FA6-40C37D775A9F}"/>
               </a:ext>
             </a:extLst>
           </p:cNvPr>
@@ -2178,7 +2178,7 @@
           <a:bodyPr/>
           <a:lstStyle/>
           <a:p>
-            <a:fld id="{46C14D9D-2B16-4C56-91DD-5F9D5BDEC962}" type="datetimeFigureOut">
+            <a:fld id="{4ABB2253-A87D-461A-BEF5-E9762CC1454B}" type="datetimeFigureOut">
               <a:rPr kumimoji="1" lang="ja-JP" altLang="en-US" smtClean="0"/>
               <a:t>2026/8/2</a:t>
             </a:fld>
@@ -2191,7 +2191,7 @@
           <p:cNvPr id="4" name="フッター プレースホルダー 3">
             <a:extLst>
               <a:ext uri="{FF2B5EF4-FFF2-40B4-BE49-F238E27FC236}">
-                <a16:creationId xmlns:a16="http://schemas.microsoft.com/office/drawing/2014/main" id="{4A5FCADA-B939-52A0-BBC5-6D80F21C680B}"/>
+                <a16:creationId xmlns:a16="http://schemas.microsoft.com/office/drawing/2014/main" id="{1516272B-EDA1-40CE-4DD8-4F420CC01B0B}"/>
               </a:ext>
             </a:extLst>
           </p:cNvPr>
@@ -2216,7 +2216,7 @@
           <p:cNvPr id="5" name="スライド番号プレースホルダー 4">
             <a:extLst>
               <a:ext uri="{FF2B5EF4-FFF2-40B4-BE49-F238E27FC236}">
-                <a16:creationId xmlns:a16="http://schemas.microsoft.com/office/drawing/2014/main" id="{DD8FECF8-6C1B-6A85-8DC0-CBD50E1D8D40}"/>
+                <a16:creationId xmlns:a16="http://schemas.microsoft.com/office/drawing/2014/main" id="{5D5FEC89-FA10-2ACD-2409-B32822E7810B}"/>
               </a:ext>
             </a:extLst>
           </p:cNvPr>
@@ -2232,7 +2232,7 @@
           <a:bodyPr/>
           <a:lstStyle/>
           <a:p>
-            <a:fld id="{20DA1BB6-7E1D-47A7-8B10-5332310EF6B2}" type="slidenum">
+            <a:fld id="{D559EA92-F8DF-420E-A5E8-4940031E9E8E}" type="slidenum">
               <a:rPr kumimoji="1" lang="ja-JP" altLang="en-US" smtClean="0"/>
               <a:t>‹#›</a:t>
             </a:fld>
@@ -2243,7 +2243,7 @@
     </p:spTree>
     <p:extLst>
       <p:ext uri="{BB962C8B-B14F-4D97-AF65-F5344CB8AC3E}">
-        <p14:creationId xmlns:p14="http://schemas.microsoft.com/office/powerpoint/2010/main" val="3082942293"/>
+        <p14:creationId xmlns:p14="http://schemas.microsoft.com/office/powerpoint/2010/main" val="4277798965"/>
       </p:ext>
     </p:extLst>
   </p:cSld>
@@ -2275,7 +2275,7 @@
           <p:cNvPr id="2" name="日付プレースホルダー 1">
             <a:extLst>
               <a:ext uri="{FF2B5EF4-FFF2-40B4-BE49-F238E27FC236}">
-                <a16:creationId xmlns:a16="http://schemas.microsoft.com/office/drawing/2014/main" id="{B6285ADD-5F7F-8E71-8B40-CD98A7C7B115}"/>
+                <a16:creationId xmlns:a16="http://schemas.microsoft.com/office/drawing/2014/main" id="{4CFF033D-5D93-CBFB-9703-F709BCD753E4}"/>
               </a:ext>
             </a:extLst>
           </p:cNvPr>
@@ -2291,7 +2291,7 @@
           <a:bodyPr/>
           <a:lstStyle/>
           <a:p>
-            <a:fld id="{46C14D9D-2B16-4C56-91DD-5F9D5BDEC962}" type="datetimeFigureOut">
+            <a:fld id="{4ABB2253-A87D-461A-BEF5-E9762CC1454B}" type="datetimeFigureOut">
               <a:rPr kumimoji="1" lang="ja-JP" altLang="en-US" smtClean="0"/>
               <a:t>2026/8/2</a:t>
             </a:fld>
@@ -2304,7 +2304,7 @@
           <p:cNvPr id="3" name="フッター プレースホルダー 2">
             <a:extLst>
               <a:ext uri="{FF2B5EF4-FFF2-40B4-BE49-F238E27FC236}">
-                <a16:creationId xmlns:a16="http://schemas.microsoft.com/office/drawing/2014/main" id="{D59724DD-B03A-E4B0-D96F-762153C56360}"/>
+                <a16:creationId xmlns:a16="http://schemas.microsoft.com/office/drawing/2014/main" id="{4E794E52-8401-559B-46A5-DBBF2B22B653}"/>
               </a:ext>
             </a:extLst>
           </p:cNvPr>
@@ -2329,7 +2329,7 @@
           <p:cNvPr id="4" name="スライド番号プレースホルダー 3">
             <a:extLst>
               <a:ext uri="{FF2B5EF4-FFF2-40B4-BE49-F238E27FC236}">
-                <a16:creationId xmlns:a16="http://schemas.microsoft.com/office/drawing/2014/main" id="{8DB27405-4F9C-FA7E-0B32-97335FE6E29D}"/>
+                <a16:creationId xmlns:a16="http://schemas.microsoft.com/office/drawing/2014/main" id="{2A3EE898-3207-5E54-4FAC-CFD2E9FBC87C}"/>
               </a:ext>
             </a:extLst>
           </p:cNvPr>
@@ -2345,7 +2345,7 @@
           <a:bodyPr/>
           <a:lstStyle/>
           <a:p>
-            <a:fld id="{20DA1BB6-7E1D-47A7-8B10-5332310EF6B2}" type="slidenum">
+            <a:fld id="{D559EA92-F8DF-420E-A5E8-4940031E9E8E}" type="slidenum">
               <a:rPr kumimoji="1" lang="ja-JP" altLang="en-US" smtClean="0"/>
               <a:t>‹#›</a:t>
             </a:fld>
@@ -2356,7 +2356,7 @@
     </p:spTree>
     <p:extLst>
       <p:ext uri="{BB962C8B-B14F-4D97-AF65-F5344CB8AC3E}">
-        <p14:creationId xmlns:p14="http://schemas.microsoft.com/office/powerpoint/2010/main" val="536630957"/>
+        <p14:creationId xmlns:p14="http://schemas.microsoft.com/office/powerpoint/2010/main" val="1868946559"/>
       </p:ext>
     </p:extLst>
   </p:cSld>
@@ -2388,7 +2388,7 @@
           <p:cNvPr id="2" name="タイトル 1">
             <a:extLst>
               <a:ext uri="{FF2B5EF4-FFF2-40B4-BE49-F238E27FC236}">
-                <a16:creationId xmlns:a16="http://schemas.microsoft.com/office/drawing/2014/main" id="{C45CCE2B-ADB1-76B2-1634-8E70B1E8BD2D}"/>
+                <a16:creationId xmlns:a16="http://schemas.microsoft.com/office/drawing/2014/main" id="{6BCBB5BD-3658-AFD9-36BA-A29180117149}"/>
               </a:ext>
             </a:extLst>
           </p:cNvPr>
@@ -2425,7 +2425,7 @@
           <p:cNvPr id="3" name="コンテンツ プレースホルダー 2">
             <a:extLst>
               <a:ext uri="{FF2B5EF4-FFF2-40B4-BE49-F238E27FC236}">
-                <a16:creationId xmlns:a16="http://schemas.microsoft.com/office/drawing/2014/main" id="{8DC2B628-9052-2E0D-2003-276E305F9500}"/>
+                <a16:creationId xmlns:a16="http://schemas.microsoft.com/office/drawing/2014/main" id="{C8C10C73-8F38-0E27-5FD7-4D749394BF76}"/>
               </a:ext>
             </a:extLst>
           </p:cNvPr>
@@ -2547,7 +2547,7 @@
           <p:cNvPr id="4" name="テキスト プレースホルダー 3">
             <a:extLst>
               <a:ext uri="{FF2B5EF4-FFF2-40B4-BE49-F238E27FC236}">
-                <a16:creationId xmlns:a16="http://schemas.microsoft.com/office/drawing/2014/main" id="{D395B7CF-CB4B-2C3A-BCB7-0C23F1EA7D44}"/>
+                <a16:creationId xmlns:a16="http://schemas.microsoft.com/office/drawing/2014/main" id="{F48234DF-4BDB-67F3-6AA3-4416EDB1B73A}"/>
               </a:ext>
             </a:extLst>
           </p:cNvPr>
@@ -2618,7 +2618,7 @@
           <p:cNvPr id="5" name="日付プレースホルダー 4">
             <a:extLst>
               <a:ext uri="{FF2B5EF4-FFF2-40B4-BE49-F238E27FC236}">
-                <a16:creationId xmlns:a16="http://schemas.microsoft.com/office/drawing/2014/main" id="{A1B64A9D-15A8-81DC-B877-9724B5ACF9C4}"/>
+                <a16:creationId xmlns:a16="http://schemas.microsoft.com/office/drawing/2014/main" id="{A5FC5228-1BBF-B8E2-6E09-3C8814D967D1}"/>
               </a:ext>
             </a:extLst>
           </p:cNvPr>
@@ -2634,7 +2634,7 @@
           <a:bodyPr/>
           <a:lstStyle/>
           <a:p>
-            <a:fld id="{46C14D9D-2B16-4C56-91DD-5F9D5BDEC962}" type="datetimeFigureOut">
+            <a:fld id="{4ABB2253-A87D-461A-BEF5-E9762CC1454B}" type="datetimeFigureOut">
               <a:rPr kumimoji="1" lang="ja-JP" altLang="en-US" smtClean="0"/>
               <a:t>2026/8/2</a:t>
             </a:fld>
@@ -2647,7 +2647,7 @@
           <p:cNvPr id="6" name="フッター プレースホルダー 5">
             <a:extLst>
               <a:ext uri="{FF2B5EF4-FFF2-40B4-BE49-F238E27FC236}">
-                <a16:creationId xmlns:a16="http://schemas.microsoft.com/office/drawing/2014/main" id="{452C4592-C8C2-F170-1C0C-F0C7C1AB442A}"/>
+                <a16:creationId xmlns:a16="http://schemas.microsoft.com/office/drawing/2014/main" id="{2684915F-702F-B894-3719-BF551962E81D}"/>
               </a:ext>
             </a:extLst>
           </p:cNvPr>
@@ -2672,7 +2672,7 @@
           <p:cNvPr id="7" name="スライド番号プレースホルダー 6">
             <a:extLst>
               <a:ext uri="{FF2B5EF4-FFF2-40B4-BE49-F238E27FC236}">
-                <a16:creationId xmlns:a16="http://schemas.microsoft.com/office/drawing/2014/main" id="{A35441BE-3EAC-2F8D-E620-7BAD8B279D84}"/>
+                <a16:creationId xmlns:a16="http://schemas.microsoft.com/office/drawing/2014/main" id="{F1CD23BF-E709-6536-D9E7-DA3DD909F2D1}"/>
               </a:ext>
             </a:extLst>
           </p:cNvPr>
@@ -2688,7 +2688,7 @@
           <a:bodyPr/>
           <a:lstStyle/>
           <a:p>
-            <a:fld id="{20DA1BB6-7E1D-47A7-8B10-5332310EF6B2}" type="slidenum">
+            <a:fld id="{D559EA92-F8DF-420E-A5E8-4940031E9E8E}" type="slidenum">
               <a:rPr kumimoji="1" lang="ja-JP" altLang="en-US" smtClean="0"/>
               <a:t>‹#›</a:t>
             </a:fld>
@@ -2699,7 +2699,7 @@
     </p:spTree>
     <p:extLst>
       <p:ext uri="{BB962C8B-B14F-4D97-AF65-F5344CB8AC3E}">
-        <p14:creationId xmlns:p14="http://schemas.microsoft.com/office/powerpoint/2010/main" val="1735522528"/>
+        <p14:creationId xmlns:p14="http://schemas.microsoft.com/office/powerpoint/2010/main" val="1391718478"/>
       </p:ext>
     </p:extLst>
   </p:cSld>
@@ -2731,7 +2731,7 @@
           <p:cNvPr id="2" name="タイトル 1">
             <a:extLst>
               <a:ext uri="{FF2B5EF4-FFF2-40B4-BE49-F238E27FC236}">
-                <a16:creationId xmlns:a16="http://schemas.microsoft.com/office/drawing/2014/main" id="{8239B6D6-8BC3-F469-4DA2-054ED4934730}"/>
+                <a16:creationId xmlns:a16="http://schemas.microsoft.com/office/drawing/2014/main" id="{B92A9F7A-F853-880B-8377-8E61B22F400E}"/>
               </a:ext>
             </a:extLst>
           </p:cNvPr>
@@ -2768,7 +2768,7 @@
           <p:cNvPr id="3" name="図プレースホルダー 2">
             <a:extLst>
               <a:ext uri="{FF2B5EF4-FFF2-40B4-BE49-F238E27FC236}">
-                <a16:creationId xmlns:a16="http://schemas.microsoft.com/office/drawing/2014/main" id="{5F364CC6-D663-8240-89C1-5EEF7CB6CF1D}"/>
+                <a16:creationId xmlns:a16="http://schemas.microsoft.com/office/drawing/2014/main" id="{1DC7D327-A3DC-53E0-558B-D9650408CEA1}"/>
               </a:ext>
             </a:extLst>
           </p:cNvPr>
@@ -2835,7 +2835,7 @@
           <p:cNvPr id="4" name="テキスト プレースホルダー 3">
             <a:extLst>
               <a:ext uri="{FF2B5EF4-FFF2-40B4-BE49-F238E27FC236}">
-                <a16:creationId xmlns:a16="http://schemas.microsoft.com/office/drawing/2014/main" id="{5DD78D4B-1A24-D70D-2CC7-A46CA82C5428}"/>
+                <a16:creationId xmlns:a16="http://schemas.microsoft.com/office/drawing/2014/main" id="{D6934B15-8F0D-48FE-D3E6-A4967B9E4050}"/>
               </a:ext>
             </a:extLst>
           </p:cNvPr>
@@ -2906,7 +2906,7 @@
           <p:cNvPr id="5" name="日付プレースホルダー 4">
             <a:extLst>
               <a:ext uri="{FF2B5EF4-FFF2-40B4-BE49-F238E27FC236}">
-                <a16:creationId xmlns:a16="http://schemas.microsoft.com/office/drawing/2014/main" id="{AEE0822B-C385-0031-89A3-B360EB65A20D}"/>
+                <a16:creationId xmlns:a16="http://schemas.microsoft.com/office/drawing/2014/main" id="{ECEF8B99-8BC1-E55C-2BBC-AE6597E5FCD0}"/>
               </a:ext>
             </a:extLst>
           </p:cNvPr>
@@ -2922,7 +2922,7 @@
           <a:bodyPr/>
           <a:lstStyle/>
           <a:p>
-            <a:fld id="{46C14D9D-2B16-4C56-91DD-5F9D5BDEC962}" type="datetimeFigureOut">
+            <a:fld id="{4ABB2253-A87D-461A-BEF5-E9762CC1454B}" type="datetimeFigureOut">
               <a:rPr kumimoji="1" lang="ja-JP" altLang="en-US" smtClean="0"/>
               <a:t>2026/8/2</a:t>
             </a:fld>
@@ -2935,7 +2935,7 @@
           <p:cNvPr id="6" name="フッター プレースホルダー 5">
             <a:extLst>
               <a:ext uri="{FF2B5EF4-FFF2-40B4-BE49-F238E27FC236}">
-                <a16:creationId xmlns:a16="http://schemas.microsoft.com/office/drawing/2014/main" id="{ABF53A0C-9EDF-4FD3-98D1-A095F3A13D54}"/>
+                <a16:creationId xmlns:a16="http://schemas.microsoft.com/office/drawing/2014/main" id="{A5D88A2B-A573-6033-C8E0-22BD2FC4C07E}"/>
               </a:ext>
             </a:extLst>
           </p:cNvPr>
@@ -2960,7 +2960,7 @@
           <p:cNvPr id="7" name="スライド番号プレースホルダー 6">
             <a:extLst>
               <a:ext uri="{FF2B5EF4-FFF2-40B4-BE49-F238E27FC236}">
-                <a16:creationId xmlns:a16="http://schemas.microsoft.com/office/drawing/2014/main" id="{F61B1858-9471-8CEF-EF22-42F244AF0FE1}"/>
+                <a16:creationId xmlns:a16="http://schemas.microsoft.com/office/drawing/2014/main" id="{036F3ABF-F443-7690-4306-EE52DA13F493}"/>
               </a:ext>
             </a:extLst>
           </p:cNvPr>
@@ -2976,7 +2976,7 @@
           <a:bodyPr/>
           <a:lstStyle/>
           <a:p>
-            <a:fld id="{20DA1BB6-7E1D-47A7-8B10-5332310EF6B2}" type="slidenum">
+            <a:fld id="{D559EA92-F8DF-420E-A5E8-4940031E9E8E}" type="slidenum">
               <a:rPr kumimoji="1" lang="ja-JP" altLang="en-US" smtClean="0"/>
               <a:t>‹#›</a:t>
             </a:fld>
@@ -2987,7 +2987,7 @@
     </p:spTree>
     <p:extLst>
       <p:ext uri="{BB962C8B-B14F-4D97-AF65-F5344CB8AC3E}">
-        <p14:creationId xmlns:p14="http://schemas.microsoft.com/office/powerpoint/2010/main" val="3011850811"/>
+        <p14:creationId xmlns:p14="http://schemas.microsoft.com/office/powerpoint/2010/main" val="3240900180"/>
       </p:ext>
     </p:extLst>
   </p:cSld>
@@ -3024,7 +3024,7 @@
           <p:cNvPr id="2" name="タイトル プレースホルダー 1">
             <a:extLst>
               <a:ext uri="{FF2B5EF4-FFF2-40B4-BE49-F238E27FC236}">
-                <a16:creationId xmlns:a16="http://schemas.microsoft.com/office/drawing/2014/main" id="{10EBFA42-DE36-E951-2F07-EFC8378C6D62}"/>
+                <a16:creationId xmlns:a16="http://schemas.microsoft.com/office/drawing/2014/main" id="{EB228F17-16C7-94BE-4562-336722A06019}"/>
               </a:ext>
             </a:extLst>
           </p:cNvPr>
@@ -3062,7 +3062,7 @@
           <p:cNvPr id="3" name="テキスト プレースホルダー 2">
             <a:extLst>
               <a:ext uri="{FF2B5EF4-FFF2-40B4-BE49-F238E27FC236}">
-                <a16:creationId xmlns:a16="http://schemas.microsoft.com/office/drawing/2014/main" id="{3484FAB4-1C69-D092-5183-E3D4908414B6}"/>
+                <a16:creationId xmlns:a16="http://schemas.microsoft.com/office/drawing/2014/main" id="{FDE045B9-776D-BB9D-57BE-F39D62B255CD}"/>
               </a:ext>
             </a:extLst>
           </p:cNvPr>
@@ -3161,7 +3161,7 @@
           <p:cNvPr id="4" name="日付プレースホルダー 3">
             <a:extLst>
               <a:ext uri="{FF2B5EF4-FFF2-40B4-BE49-F238E27FC236}">
-                <a16:creationId xmlns:a16="http://schemas.microsoft.com/office/drawing/2014/main" id="{443DBA42-CE2B-EA53-B6B0-0E5ECEB21536}"/>
+                <a16:creationId xmlns:a16="http://schemas.microsoft.com/office/drawing/2014/main" id="{115927C0-AEF6-65C8-B18C-9C85909B3674}"/>
               </a:ext>
             </a:extLst>
           </p:cNvPr>
@@ -3195,7 +3195,7 @@
             </a:lvl1pPr>
           </a:lstStyle>
           <a:p>
-            <a:fld id="{46C14D9D-2B16-4C56-91DD-5F9D5BDEC962}" type="datetimeFigureOut">
+            <a:fld id="{4ABB2253-A87D-461A-BEF5-E9762CC1454B}" type="datetimeFigureOut">
               <a:rPr kumimoji="1" lang="ja-JP" altLang="en-US" smtClean="0"/>
               <a:t>2026/8/2</a:t>
             </a:fld>
@@ -3208,7 +3208,7 @@
           <p:cNvPr id="5" name="フッター プレースホルダー 4">
             <a:extLst>
               <a:ext uri="{FF2B5EF4-FFF2-40B4-BE49-F238E27FC236}">
-                <a16:creationId xmlns:a16="http://schemas.microsoft.com/office/drawing/2014/main" id="{1795D717-7B3F-7AA4-4181-124A79C93EF0}"/>
+                <a16:creationId xmlns:a16="http://schemas.microsoft.com/office/drawing/2014/main" id="{35E2B1C2-BF94-BC67-A4C9-14A8A4E400F0}"/>
               </a:ext>
             </a:extLst>
           </p:cNvPr>
@@ -3251,7 +3251,7 @@
           <p:cNvPr id="6" name="スライド番号プレースホルダー 5">
             <a:extLst>
               <a:ext uri="{FF2B5EF4-FFF2-40B4-BE49-F238E27FC236}">
-                <a16:creationId xmlns:a16="http://schemas.microsoft.com/office/drawing/2014/main" id="{D6FD17F7-EC8A-9AFE-9A49-D5022F888015}"/>
+                <a16:creationId xmlns:a16="http://schemas.microsoft.com/office/drawing/2014/main" id="{A144390E-E1A8-5318-385F-57F0FAF08E1C}"/>
               </a:ext>
             </a:extLst>
           </p:cNvPr>
@@ -3285,7 +3285,7 @@
             </a:lvl1pPr>
           </a:lstStyle>
           <a:p>
-            <a:fld id="{20DA1BB6-7E1D-47A7-8B10-5332310EF6B2}" type="slidenum">
+            <a:fld id="{D559EA92-F8DF-420E-A5E8-4940031E9E8E}" type="slidenum">
               <a:rPr kumimoji="1" lang="ja-JP" altLang="en-US" smtClean="0"/>
               <a:t>‹#›</a:t>
             </a:fld>
@@ -3296,7 +3296,7 @@
     </p:spTree>
     <p:extLst>
       <p:ext uri="{BB962C8B-B14F-4D97-AF65-F5344CB8AC3E}">
-        <p14:creationId xmlns:p14="http://schemas.microsoft.com/office/powerpoint/2010/main" val="1439023926"/>
+        <p14:creationId xmlns:p14="http://schemas.microsoft.com/office/powerpoint/2010/main" val="610316873"/>
       </p:ext>
     </p:extLst>
   </p:cSld>
@@ -3619,7 +3619,7 @@
           <p:cNvPr id="2" name="テキスト ボックス 1">
             <a:extLst>
               <a:ext uri="{FF2B5EF4-FFF2-40B4-BE49-F238E27FC236}">
-                <a16:creationId xmlns:a16="http://schemas.microsoft.com/office/drawing/2014/main" id="{51A723F9-545A-2049-BC71-0B688B9F2A01}"/>
+                <a16:creationId xmlns:a16="http://schemas.microsoft.com/office/drawing/2014/main" id="{623432BB-ACF9-86D7-38EB-105E1C0EFFC9}"/>
               </a:ext>
             </a:extLst>
           </p:cNvPr>
@@ -3643,13 +3643,49 @@
           <a:lstStyle/>
           <a:p>
             <a:r>
-              <a:rPr kumimoji="1" lang="en-US" altLang="ja-JP" sz="1600" b="1">
+              <a:rPr kumimoji="1" lang="zh-TW" altLang="en-US" sz="1600" b="1">
                 <a:solidFill>
                   <a:srgbClr val="556F35"/>
                 </a:solidFill>
                 <a:latin typeface="Arial" panose="020B0604020202020204" pitchFamily="34" charset="0"/>
               </a:rPr>
-              <a:t>TSUMIAGE LOG / TECH VIDEO</a:t>
+              <a:t>遨阪∩荳翫￡繝ｭ繧ｰ </a:t>
+            </a:r>
+            <a:r>
+              <a:rPr kumimoji="1" lang="en-US" altLang="zh-TW" sz="1600" b="1">
+                <a:solidFill>
+                  <a:srgbClr val="556F35"/>
+                </a:solidFill>
+                <a:latin typeface="Arial" panose="020B0604020202020204" pitchFamily="34" charset="0"/>
+              </a:rPr>
+              <a:t>/ </a:t>
+            </a:r>
+            <a:r>
+              <a:rPr kumimoji="1" lang="zh-TW" altLang="en-US" sz="1600" b="1">
+                <a:solidFill>
+                  <a:srgbClr val="556F35"/>
+                </a:solidFill>
+                <a:latin typeface="Arial" panose="020B0604020202020204" pitchFamily="34" charset="0"/>
+              </a:rPr>
+              <a:t>謚陦楢ｧ</a:t>
+            </a:r>
+            <a:r>
+              <a:rPr kumimoji="1" lang="en-US" altLang="zh-TW" sz="1600" b="1">
+                <a:solidFill>
+                  <a:srgbClr val="556F35"/>
+                </a:solidFill>
+                <a:latin typeface="Arial" panose="020B0604020202020204" pitchFamily="34" charset="0"/>
+              </a:rPr>
+              <a:t>｣</a:t>
+            </a:r>
+            <a:r>
+              <a:rPr kumimoji="1" lang="zh-TW" altLang="en-US" sz="1600" b="1">
+                <a:solidFill>
+                  <a:srgbClr val="556F35"/>
+                </a:solidFill>
+                <a:latin typeface="Arial" panose="020B0604020202020204" pitchFamily="34" charset="0"/>
+              </a:rPr>
+              <a:t>隱ｬ蜍慕判</a:t>
             </a:r>
             <a:endParaRPr kumimoji="1" lang="ja-JP" altLang="en-US" sz="1600" b="1">
               <a:solidFill>
@@ -3665,7 +3701,7 @@
           <p:cNvPr id="3" name="テキスト ボックス 2">
             <a:extLst>
               <a:ext uri="{FF2B5EF4-FFF2-40B4-BE49-F238E27FC236}">
-                <a16:creationId xmlns:a16="http://schemas.microsoft.com/office/drawing/2014/main" id="{C9CE572B-3E1C-F034-4D13-7B549C0D7FE5}"/>
+                <a16:creationId xmlns:a16="http://schemas.microsoft.com/office/drawing/2014/main" id="{FFA248E5-C104-550C-8677-5BB865E4EFFD}"/>
               </a:ext>
             </a:extLst>
           </p:cNvPr>
@@ -3714,7 +3750,7 @@
           <p:cNvPr id="4" name="テキスト ボックス 3">
             <a:extLst>
               <a:ext uri="{FF2B5EF4-FFF2-40B4-BE49-F238E27FC236}">
-                <a16:creationId xmlns:a16="http://schemas.microsoft.com/office/drawing/2014/main" id="{C66C74C0-5314-37C0-3CB0-87CB620F73F6}"/>
+                <a16:creationId xmlns:a16="http://schemas.microsoft.com/office/drawing/2014/main" id="{F5277485-C633-2B73-0A09-10641E4A0E5A}"/>
               </a:ext>
             </a:extLst>
           </p:cNvPr>
@@ -3744,7 +3780,7 @@
                 </a:solidFill>
                 <a:latin typeface="Arial" panose="020B0604020202020204" pitchFamily="34" charset="0"/>
               </a:rPr>
-              <a:t>設計・実装・コミットから学ぶ短時間プレビュー</a:t>
+              <a:t>設計・実装・コミットから学ぶ短時間の技術解説</a:t>
             </a:r>
           </a:p>
         </p:txBody>
@@ -3754,7 +3790,7 @@
           <p:cNvPr id="5" name="テキスト ボックス 4">
             <a:extLst>
               <a:ext uri="{FF2B5EF4-FFF2-40B4-BE49-F238E27FC236}">
-                <a16:creationId xmlns:a16="http://schemas.microsoft.com/office/drawing/2014/main" id="{FDB24DC4-B3BC-2443-7139-D9530E570B48}"/>
+                <a16:creationId xmlns:a16="http://schemas.microsoft.com/office/drawing/2014/main" id="{E8B221AC-149E-995D-4B1E-2BD3B88B8221}"/>
               </a:ext>
             </a:extLst>
           </p:cNvPr>
@@ -3801,7 +3837,7 @@
             <a:hlinkClick r:id="" action="ppaction://media"/>
             <a:extLst>
               <a:ext uri="{FF2B5EF4-FFF2-40B4-BE49-F238E27FC236}">
-                <a16:creationId xmlns:a16="http://schemas.microsoft.com/office/drawing/2014/main" id="{D0392C0A-6A25-E12B-3084-A1933682AF7D}"/>
+                <a16:creationId xmlns:a16="http://schemas.microsoft.com/office/drawing/2014/main" id="{2B7D017F-2311-AE97-9306-F4CF7E11AFC8}"/>
               </a:ext>
             </a:extLst>
           </p:cNvPr>
@@ -3836,7 +3872,7 @@
     </p:spTree>
     <p:extLst>
       <p:ext uri="{BB962C8B-B14F-4D97-AF65-F5344CB8AC3E}">
-        <p14:creationId xmlns:p14="http://schemas.microsoft.com/office/powerpoint/2010/main" val="2314909381"/>
+        <p14:creationId xmlns:p14="http://schemas.microsoft.com/office/powerpoint/2010/main" val="2268539316"/>
       </p:ext>
     </p:extLst>
   </p:cSld>
@@ -3960,7 +3996,7 @@
           <p:cNvPr id="2" name="テキスト ボックス 1">
             <a:extLst>
               <a:ext uri="{FF2B5EF4-FFF2-40B4-BE49-F238E27FC236}">
-                <a16:creationId xmlns:a16="http://schemas.microsoft.com/office/drawing/2014/main" id="{88F4AA00-87E8-58E9-08A6-5F7591AA7FF2}"/>
+                <a16:creationId xmlns:a16="http://schemas.microsoft.com/office/drawing/2014/main" id="{05F67EDE-A49C-5D94-9AA1-D44293F54262}"/>
               </a:ext>
             </a:extLst>
           </p:cNvPr>
@@ -3984,13 +4020,49 @@
           <a:lstStyle/>
           <a:p>
             <a:r>
-              <a:rPr kumimoji="1" lang="en-US" altLang="ja-JP" sz="1600" b="1">
+              <a:rPr kumimoji="1" lang="zh-TW" altLang="en-US" sz="1600" b="1">
                 <a:solidFill>
                   <a:srgbClr val="556F35"/>
                 </a:solidFill>
                 <a:latin typeface="Arial" panose="020B0604020202020204" pitchFamily="34" charset="0"/>
               </a:rPr>
-              <a:t>TSUMIAGE LOG / TECH VIDEO</a:t>
+              <a:t>遨阪∩荳翫￡繝ｭ繧ｰ </a:t>
+            </a:r>
+            <a:r>
+              <a:rPr kumimoji="1" lang="en-US" altLang="zh-TW" sz="1600" b="1">
+                <a:solidFill>
+                  <a:srgbClr val="556F35"/>
+                </a:solidFill>
+                <a:latin typeface="Arial" panose="020B0604020202020204" pitchFamily="34" charset="0"/>
+              </a:rPr>
+              <a:t>/ </a:t>
+            </a:r>
+            <a:r>
+              <a:rPr kumimoji="1" lang="zh-TW" altLang="en-US" sz="1600" b="1">
+                <a:solidFill>
+                  <a:srgbClr val="556F35"/>
+                </a:solidFill>
+                <a:latin typeface="Arial" panose="020B0604020202020204" pitchFamily="34" charset="0"/>
+              </a:rPr>
+              <a:t>謚陦楢ｧ</a:t>
+            </a:r>
+            <a:r>
+              <a:rPr kumimoji="1" lang="en-US" altLang="zh-TW" sz="1600" b="1">
+                <a:solidFill>
+                  <a:srgbClr val="556F35"/>
+                </a:solidFill>
+                <a:latin typeface="Arial" panose="020B0604020202020204" pitchFamily="34" charset="0"/>
+              </a:rPr>
+              <a:t>｣</a:t>
+            </a:r>
+            <a:r>
+              <a:rPr kumimoji="1" lang="zh-TW" altLang="en-US" sz="1600" b="1">
+                <a:solidFill>
+                  <a:srgbClr val="556F35"/>
+                </a:solidFill>
+                <a:latin typeface="Arial" panose="020B0604020202020204" pitchFamily="34" charset="0"/>
+              </a:rPr>
+              <a:t>隱ｬ蜍慕判</a:t>
             </a:r>
             <a:endParaRPr kumimoji="1" lang="ja-JP" altLang="en-US" sz="1600" b="1">
               <a:solidFill>
@@ -4006,7 +4078,7 @@
           <p:cNvPr id="3" name="テキスト ボックス 2">
             <a:extLst>
               <a:ext uri="{FF2B5EF4-FFF2-40B4-BE49-F238E27FC236}">
-                <a16:creationId xmlns:a16="http://schemas.microsoft.com/office/drawing/2014/main" id="{ED10D5EE-7F20-62E7-97DB-F7E698874409}"/>
+                <a16:creationId xmlns:a16="http://schemas.microsoft.com/office/drawing/2014/main" id="{932D8EC4-1271-C347-438E-9F6C5654A713}"/>
               </a:ext>
             </a:extLst>
           </p:cNvPr>
@@ -4046,7 +4118,7 @@
           <p:cNvPr id="4" name="テキスト ボックス 3">
             <a:extLst>
               <a:ext uri="{FF2B5EF4-FFF2-40B4-BE49-F238E27FC236}">
-                <a16:creationId xmlns:a16="http://schemas.microsoft.com/office/drawing/2014/main" id="{574A4253-CDF8-74A6-6BC7-E1D2E1E30758}"/>
+                <a16:creationId xmlns:a16="http://schemas.microsoft.com/office/drawing/2014/main" id="{C853EEA1-BA31-3F14-BDAB-72C0B8148F05}"/>
               </a:ext>
             </a:extLst>
           </p:cNvPr>
@@ -4149,7 +4221,7 @@
           <p:cNvPr id="5" name="テキスト ボックス 4">
             <a:extLst>
               <a:ext uri="{FF2B5EF4-FFF2-40B4-BE49-F238E27FC236}">
-                <a16:creationId xmlns:a16="http://schemas.microsoft.com/office/drawing/2014/main" id="{E5217FEB-18F0-7A8E-89F1-395DEE27007A}"/>
+                <a16:creationId xmlns:a16="http://schemas.microsoft.com/office/drawing/2014/main" id="{9B164A2F-F58F-31F0-8024-F873A12E0590}"/>
               </a:ext>
             </a:extLst>
           </p:cNvPr>
@@ -4196,7 +4268,7 @@
             <a:hlinkClick r:id="" action="ppaction://media"/>
             <a:extLst>
               <a:ext uri="{FF2B5EF4-FFF2-40B4-BE49-F238E27FC236}">
-                <a16:creationId xmlns:a16="http://schemas.microsoft.com/office/drawing/2014/main" id="{33FE3514-B0B1-C020-8CDD-DEFB17BB6056}"/>
+                <a16:creationId xmlns:a16="http://schemas.microsoft.com/office/drawing/2014/main" id="{86FBE652-7614-6AE3-2E65-5F1EEEDCE571}"/>
               </a:ext>
             </a:extLst>
           </p:cNvPr>
@@ -4231,7 +4303,7 @@
     </p:spTree>
     <p:extLst>
       <p:ext uri="{BB962C8B-B14F-4D97-AF65-F5344CB8AC3E}">
-        <p14:creationId xmlns:p14="http://schemas.microsoft.com/office/powerpoint/2010/main" val="1668294971"/>
+        <p14:creationId xmlns:p14="http://schemas.microsoft.com/office/powerpoint/2010/main" val="1717018984"/>
       </p:ext>
     </p:extLst>
   </p:cSld>
@@ -4355,7 +4427,7 @@
           <p:cNvPr id="2" name="テキスト ボックス 1">
             <a:extLst>
               <a:ext uri="{FF2B5EF4-FFF2-40B4-BE49-F238E27FC236}">
-                <a16:creationId xmlns:a16="http://schemas.microsoft.com/office/drawing/2014/main" id="{FC218352-7EBC-4955-5291-96A5354646D4}"/>
+                <a16:creationId xmlns:a16="http://schemas.microsoft.com/office/drawing/2014/main" id="{34ACFAC0-2DDF-77DB-A6C7-CEE6EFDB4E5B}"/>
               </a:ext>
             </a:extLst>
           </p:cNvPr>
@@ -4379,13 +4451,49 @@
           <a:lstStyle/>
           <a:p>
             <a:r>
-              <a:rPr kumimoji="1" lang="en-US" altLang="ja-JP" sz="1600" b="1">
+              <a:rPr kumimoji="1" lang="zh-TW" altLang="en-US" sz="1600" b="1">
                 <a:solidFill>
                   <a:srgbClr val="556F35"/>
                 </a:solidFill>
                 <a:latin typeface="Arial" panose="020B0604020202020204" pitchFamily="34" charset="0"/>
               </a:rPr>
-              <a:t>TSUMIAGE LOG / TECH VIDEO</a:t>
+              <a:t>遨阪∩荳翫￡繝ｭ繧ｰ </a:t>
+            </a:r>
+            <a:r>
+              <a:rPr kumimoji="1" lang="en-US" altLang="zh-TW" sz="1600" b="1">
+                <a:solidFill>
+                  <a:srgbClr val="556F35"/>
+                </a:solidFill>
+                <a:latin typeface="Arial" panose="020B0604020202020204" pitchFamily="34" charset="0"/>
+              </a:rPr>
+              <a:t>/ </a:t>
+            </a:r>
+            <a:r>
+              <a:rPr kumimoji="1" lang="zh-TW" altLang="en-US" sz="1600" b="1">
+                <a:solidFill>
+                  <a:srgbClr val="556F35"/>
+                </a:solidFill>
+                <a:latin typeface="Arial" panose="020B0604020202020204" pitchFamily="34" charset="0"/>
+              </a:rPr>
+              <a:t>謚陦楢ｧ</a:t>
+            </a:r>
+            <a:r>
+              <a:rPr kumimoji="1" lang="en-US" altLang="zh-TW" sz="1600" b="1">
+                <a:solidFill>
+                  <a:srgbClr val="556F35"/>
+                </a:solidFill>
+                <a:latin typeface="Arial" panose="020B0604020202020204" pitchFamily="34" charset="0"/>
+              </a:rPr>
+              <a:t>｣</a:t>
+            </a:r>
+            <a:r>
+              <a:rPr kumimoji="1" lang="zh-TW" altLang="en-US" sz="1600" b="1">
+                <a:solidFill>
+                  <a:srgbClr val="556F35"/>
+                </a:solidFill>
+                <a:latin typeface="Arial" panose="020B0604020202020204" pitchFamily="34" charset="0"/>
+              </a:rPr>
+              <a:t>隱ｬ蜍慕判</a:t>
             </a:r>
             <a:endParaRPr kumimoji="1" lang="ja-JP" altLang="en-US" sz="1600" b="1">
               <a:solidFill>
@@ -4401,7 +4509,7 @@
           <p:cNvPr id="3" name="テキスト ボックス 2">
             <a:extLst>
               <a:ext uri="{FF2B5EF4-FFF2-40B4-BE49-F238E27FC236}">
-                <a16:creationId xmlns:a16="http://schemas.microsoft.com/office/drawing/2014/main" id="{BE8E5D36-BF94-049F-635F-51CF082AB312}"/>
+                <a16:creationId xmlns:a16="http://schemas.microsoft.com/office/drawing/2014/main" id="{33F3DABA-5E07-3DB7-BCA6-FA75B9C15400}"/>
               </a:ext>
             </a:extLst>
           </p:cNvPr>
@@ -4441,7 +4549,7 @@
           <p:cNvPr id="4" name="テキスト ボックス 3">
             <a:extLst>
               <a:ext uri="{FF2B5EF4-FFF2-40B4-BE49-F238E27FC236}">
-                <a16:creationId xmlns:a16="http://schemas.microsoft.com/office/drawing/2014/main" id="{31AC8680-C72E-32D6-D2E6-4E7335D63DEB}"/>
+                <a16:creationId xmlns:a16="http://schemas.microsoft.com/office/drawing/2014/main" id="{DFD34C1A-B8EE-5F63-79C8-6DC739257F97}"/>
               </a:ext>
             </a:extLst>
           </p:cNvPr>
@@ -4536,7 +4644,7 @@
           <p:cNvPr id="5" name="テキスト ボックス 4">
             <a:extLst>
               <a:ext uri="{FF2B5EF4-FFF2-40B4-BE49-F238E27FC236}">
-                <a16:creationId xmlns:a16="http://schemas.microsoft.com/office/drawing/2014/main" id="{9185EA20-9E6C-1AD2-1D52-E37D8B731247}"/>
+                <a16:creationId xmlns:a16="http://schemas.microsoft.com/office/drawing/2014/main" id="{1C27C3A1-C8CB-EBB6-29B5-DE1632958A05}"/>
               </a:ext>
             </a:extLst>
           </p:cNvPr>
@@ -4583,7 +4691,7 @@
             <a:hlinkClick r:id="" action="ppaction://media"/>
             <a:extLst>
               <a:ext uri="{FF2B5EF4-FFF2-40B4-BE49-F238E27FC236}">
-                <a16:creationId xmlns:a16="http://schemas.microsoft.com/office/drawing/2014/main" id="{435300E9-028F-990E-16EB-2A02500B3132}"/>
+                <a16:creationId xmlns:a16="http://schemas.microsoft.com/office/drawing/2014/main" id="{1B8A6D3F-DF90-084A-4CBB-2DC91D723756}"/>
               </a:ext>
             </a:extLst>
           </p:cNvPr>
@@ -4618,7 +4726,7 @@
     </p:spTree>
     <p:extLst>
       <p:ext uri="{BB962C8B-B14F-4D97-AF65-F5344CB8AC3E}">
-        <p14:creationId xmlns:p14="http://schemas.microsoft.com/office/powerpoint/2010/main" val="476233573"/>
+        <p14:creationId xmlns:p14="http://schemas.microsoft.com/office/powerpoint/2010/main" val="2482021698"/>
       </p:ext>
     </p:extLst>
   </p:cSld>
@@ -4742,7 +4850,7 @@
           <p:cNvPr id="2" name="テキスト ボックス 1">
             <a:extLst>
               <a:ext uri="{FF2B5EF4-FFF2-40B4-BE49-F238E27FC236}">
-                <a16:creationId xmlns:a16="http://schemas.microsoft.com/office/drawing/2014/main" id="{E25CBBD3-2751-B37C-1C29-EC33AAAE2018}"/>
+                <a16:creationId xmlns:a16="http://schemas.microsoft.com/office/drawing/2014/main" id="{21BCB48E-A399-CE43-BD80-4406BE7FE58F}"/>
               </a:ext>
             </a:extLst>
           </p:cNvPr>
@@ -4766,13 +4874,49 @@
           <a:lstStyle/>
           <a:p>
             <a:r>
-              <a:rPr kumimoji="1" lang="en-US" altLang="ja-JP" sz="1600" b="1">
+              <a:rPr kumimoji="1" lang="zh-TW" altLang="en-US" sz="1600" b="1">
                 <a:solidFill>
                   <a:srgbClr val="556F35"/>
                 </a:solidFill>
                 <a:latin typeface="Arial" panose="020B0604020202020204" pitchFamily="34" charset="0"/>
               </a:rPr>
-              <a:t>TSUMIAGE LOG / TECH VIDEO</a:t>
+              <a:t>遨阪∩荳翫￡繝ｭ繧ｰ </a:t>
+            </a:r>
+            <a:r>
+              <a:rPr kumimoji="1" lang="en-US" altLang="zh-TW" sz="1600" b="1">
+                <a:solidFill>
+                  <a:srgbClr val="556F35"/>
+                </a:solidFill>
+                <a:latin typeface="Arial" panose="020B0604020202020204" pitchFamily="34" charset="0"/>
+              </a:rPr>
+              <a:t>/ </a:t>
+            </a:r>
+            <a:r>
+              <a:rPr kumimoji="1" lang="zh-TW" altLang="en-US" sz="1600" b="1">
+                <a:solidFill>
+                  <a:srgbClr val="556F35"/>
+                </a:solidFill>
+                <a:latin typeface="Arial" panose="020B0604020202020204" pitchFamily="34" charset="0"/>
+              </a:rPr>
+              <a:t>謚陦楢ｧ</a:t>
+            </a:r>
+            <a:r>
+              <a:rPr kumimoji="1" lang="en-US" altLang="zh-TW" sz="1600" b="1">
+                <a:solidFill>
+                  <a:srgbClr val="556F35"/>
+                </a:solidFill>
+                <a:latin typeface="Arial" panose="020B0604020202020204" pitchFamily="34" charset="0"/>
+              </a:rPr>
+              <a:t>｣</a:t>
+            </a:r>
+            <a:r>
+              <a:rPr kumimoji="1" lang="zh-TW" altLang="en-US" sz="1600" b="1">
+                <a:solidFill>
+                  <a:srgbClr val="556F35"/>
+                </a:solidFill>
+                <a:latin typeface="Arial" panose="020B0604020202020204" pitchFamily="34" charset="0"/>
+              </a:rPr>
+              <a:t>隱ｬ蜍慕判</a:t>
             </a:r>
             <a:endParaRPr kumimoji="1" lang="ja-JP" altLang="en-US" sz="1600" b="1">
               <a:solidFill>
@@ -4788,7 +4932,7 @@
           <p:cNvPr id="3" name="テキスト ボックス 2">
             <a:extLst>
               <a:ext uri="{FF2B5EF4-FFF2-40B4-BE49-F238E27FC236}">
-                <a16:creationId xmlns:a16="http://schemas.microsoft.com/office/drawing/2014/main" id="{7B2E67E1-3AEF-9FA9-6112-E126E5A955E7}"/>
+                <a16:creationId xmlns:a16="http://schemas.microsoft.com/office/drawing/2014/main" id="{24A2C5F0-ADFB-F3F6-3E2D-4718D26F11CD}"/>
               </a:ext>
             </a:extLst>
           </p:cNvPr>
@@ -4828,7 +4972,7 @@
           <p:cNvPr id="4" name="テキスト ボックス 3">
             <a:extLst>
               <a:ext uri="{FF2B5EF4-FFF2-40B4-BE49-F238E27FC236}">
-                <a16:creationId xmlns:a16="http://schemas.microsoft.com/office/drawing/2014/main" id="{B1E72FD3-5A7D-4C77-BA6A-42DBC7308B2E}"/>
+                <a16:creationId xmlns:a16="http://schemas.microsoft.com/office/drawing/2014/main" id="{E06F6C7F-AAC9-B4F3-0FAA-AF1A4CC8861B}"/>
               </a:ext>
             </a:extLst>
           </p:cNvPr>
@@ -4938,7 +5082,7 @@
           <p:cNvPr id="5" name="テキスト ボックス 4">
             <a:extLst>
               <a:ext uri="{FF2B5EF4-FFF2-40B4-BE49-F238E27FC236}">
-                <a16:creationId xmlns:a16="http://schemas.microsoft.com/office/drawing/2014/main" id="{D815DB2F-6A2B-75AD-4AD9-EA0D3B93FEBB}"/>
+                <a16:creationId xmlns:a16="http://schemas.microsoft.com/office/drawing/2014/main" id="{F521594D-A7AF-E679-0D9C-0A038724ABA9}"/>
               </a:ext>
             </a:extLst>
           </p:cNvPr>
@@ -4985,7 +5129,7 @@
             <a:hlinkClick r:id="" action="ppaction://media"/>
             <a:extLst>
               <a:ext uri="{FF2B5EF4-FFF2-40B4-BE49-F238E27FC236}">
-                <a16:creationId xmlns:a16="http://schemas.microsoft.com/office/drawing/2014/main" id="{8EA7DF89-6C7D-83D8-2CBB-E81298D3E09D}"/>
+                <a16:creationId xmlns:a16="http://schemas.microsoft.com/office/drawing/2014/main" id="{B2872CB5-2DDD-54BE-16FA-7F64B5F70FCE}"/>
               </a:ext>
             </a:extLst>
           </p:cNvPr>
@@ -5020,7 +5164,7 @@
     </p:spTree>
     <p:extLst>
       <p:ext uri="{BB962C8B-B14F-4D97-AF65-F5344CB8AC3E}">
-        <p14:creationId xmlns:p14="http://schemas.microsoft.com/office/powerpoint/2010/main" val="2933440001"/>
+        <p14:creationId xmlns:p14="http://schemas.microsoft.com/office/powerpoint/2010/main" val="1217545784"/>
       </p:ext>
     </p:extLst>
   </p:cSld>
@@ -5144,7 +5288,7 @@
           <p:cNvPr id="2" name="テキスト ボックス 1">
             <a:extLst>
               <a:ext uri="{FF2B5EF4-FFF2-40B4-BE49-F238E27FC236}">
-                <a16:creationId xmlns:a16="http://schemas.microsoft.com/office/drawing/2014/main" id="{15EC730C-B1B0-0C2F-4CB7-6E25751B83E9}"/>
+                <a16:creationId xmlns:a16="http://schemas.microsoft.com/office/drawing/2014/main" id="{539E687F-9E72-C8D0-7384-BDA2B3718E3E}"/>
               </a:ext>
             </a:extLst>
           </p:cNvPr>
@@ -5168,13 +5312,49 @@
           <a:lstStyle/>
           <a:p>
             <a:r>
-              <a:rPr kumimoji="1" lang="en-US" altLang="ja-JP" sz="1600" b="1">
+              <a:rPr kumimoji="1" lang="zh-TW" altLang="en-US" sz="1600" b="1">
                 <a:solidFill>
                   <a:srgbClr val="556F35"/>
                 </a:solidFill>
                 <a:latin typeface="Arial" panose="020B0604020202020204" pitchFamily="34" charset="0"/>
               </a:rPr>
-              <a:t>TSUMIAGE LOG / TECH VIDEO</a:t>
+              <a:t>遨阪∩荳翫￡繝ｭ繧ｰ </a:t>
+            </a:r>
+            <a:r>
+              <a:rPr kumimoji="1" lang="en-US" altLang="zh-TW" sz="1600" b="1">
+                <a:solidFill>
+                  <a:srgbClr val="556F35"/>
+                </a:solidFill>
+                <a:latin typeface="Arial" panose="020B0604020202020204" pitchFamily="34" charset="0"/>
+              </a:rPr>
+              <a:t>/ </a:t>
+            </a:r>
+            <a:r>
+              <a:rPr kumimoji="1" lang="zh-TW" altLang="en-US" sz="1600" b="1">
+                <a:solidFill>
+                  <a:srgbClr val="556F35"/>
+                </a:solidFill>
+                <a:latin typeface="Arial" panose="020B0604020202020204" pitchFamily="34" charset="0"/>
+              </a:rPr>
+              <a:t>謚陦楢ｧ</a:t>
+            </a:r>
+            <a:r>
+              <a:rPr kumimoji="1" lang="en-US" altLang="zh-TW" sz="1600" b="1">
+                <a:solidFill>
+                  <a:srgbClr val="556F35"/>
+                </a:solidFill>
+                <a:latin typeface="Arial" panose="020B0604020202020204" pitchFamily="34" charset="0"/>
+              </a:rPr>
+              <a:t>｣</a:t>
+            </a:r>
+            <a:r>
+              <a:rPr kumimoji="1" lang="zh-TW" altLang="en-US" sz="1600" b="1">
+                <a:solidFill>
+                  <a:srgbClr val="556F35"/>
+                </a:solidFill>
+                <a:latin typeface="Arial" panose="020B0604020202020204" pitchFamily="34" charset="0"/>
+              </a:rPr>
+              <a:t>隱ｬ蜍慕判</a:t>
             </a:r>
             <a:endParaRPr kumimoji="1" lang="ja-JP" altLang="en-US" sz="1600" b="1">
               <a:solidFill>
@@ -5190,7 +5370,7 @@
           <p:cNvPr id="3" name="テキスト ボックス 2">
             <a:extLst>
               <a:ext uri="{FF2B5EF4-FFF2-40B4-BE49-F238E27FC236}">
-                <a16:creationId xmlns:a16="http://schemas.microsoft.com/office/drawing/2014/main" id="{D63D0D09-C77E-AF92-AD35-16943C95990F}"/>
+                <a16:creationId xmlns:a16="http://schemas.microsoft.com/office/drawing/2014/main" id="{722DDB55-D40E-118B-9228-CA9E7AB55B06}"/>
               </a:ext>
             </a:extLst>
           </p:cNvPr>
@@ -5230,7 +5410,7 @@
           <p:cNvPr id="4" name="テキスト ボックス 3">
             <a:extLst>
               <a:ext uri="{FF2B5EF4-FFF2-40B4-BE49-F238E27FC236}">
-                <a16:creationId xmlns:a16="http://schemas.microsoft.com/office/drawing/2014/main" id="{CF1C7453-ACEF-F738-511B-716AB8AE12E1}"/>
+                <a16:creationId xmlns:a16="http://schemas.microsoft.com/office/drawing/2014/main" id="{3BD69980-E6F1-D8BC-7250-994F96819338}"/>
               </a:ext>
             </a:extLst>
           </p:cNvPr>
@@ -5270,7 +5450,7 @@
           <p:cNvPr id="5" name="テキスト ボックス 4">
             <a:extLst>
               <a:ext uri="{FF2B5EF4-FFF2-40B4-BE49-F238E27FC236}">
-                <a16:creationId xmlns:a16="http://schemas.microsoft.com/office/drawing/2014/main" id="{AA0514DD-27E4-2C7B-4E36-A9B036AA64A4}"/>
+                <a16:creationId xmlns:a16="http://schemas.microsoft.com/office/drawing/2014/main" id="{8F051C23-29DC-026D-635F-139D8CB10196}"/>
               </a:ext>
             </a:extLst>
           </p:cNvPr>
@@ -5317,7 +5497,7 @@
             <a:hlinkClick r:id="" action="ppaction://media"/>
             <a:extLst>
               <a:ext uri="{FF2B5EF4-FFF2-40B4-BE49-F238E27FC236}">
-                <a16:creationId xmlns:a16="http://schemas.microsoft.com/office/drawing/2014/main" id="{01CF1329-1F0E-4DAD-47AF-799FCDA116ED}"/>
+                <a16:creationId xmlns:a16="http://schemas.microsoft.com/office/drawing/2014/main" id="{9BACC697-6866-80EE-6F71-AB050DED8DEB}"/>
               </a:ext>
             </a:extLst>
           </p:cNvPr>
@@ -5352,7 +5532,7 @@
     </p:spTree>
     <p:extLst>
       <p:ext uri="{BB962C8B-B14F-4D97-AF65-F5344CB8AC3E}">
-        <p14:creationId xmlns:p14="http://schemas.microsoft.com/office/powerpoint/2010/main" val="2062035346"/>
+        <p14:creationId xmlns:p14="http://schemas.microsoft.com/office/powerpoint/2010/main" val="3047413724"/>
       </p:ext>
     </p:extLst>
   </p:cSld>
@@ -5476,7 +5656,7 @@
           <p:cNvPr id="2" name="テキスト ボックス 1">
             <a:extLst>
               <a:ext uri="{FF2B5EF4-FFF2-40B4-BE49-F238E27FC236}">
-                <a16:creationId xmlns:a16="http://schemas.microsoft.com/office/drawing/2014/main" id="{F2D6B6D1-8DD6-B0C0-2137-2DAC6A9840D6}"/>
+                <a16:creationId xmlns:a16="http://schemas.microsoft.com/office/drawing/2014/main" id="{5FABFDFD-EFB6-01DD-5E75-FE7FDFDE30AC}"/>
               </a:ext>
             </a:extLst>
           </p:cNvPr>
@@ -5500,13 +5680,49 @@
           <a:lstStyle/>
           <a:p>
             <a:r>
-              <a:rPr kumimoji="1" lang="en-US" altLang="ja-JP" sz="1600" b="1">
+              <a:rPr kumimoji="1" lang="zh-TW" altLang="en-US" sz="1600" b="1">
                 <a:solidFill>
                   <a:srgbClr val="556F35"/>
                 </a:solidFill>
                 <a:latin typeface="Arial" panose="020B0604020202020204" pitchFamily="34" charset="0"/>
               </a:rPr>
-              <a:t>TSUMIAGE LOG / TECH VIDEO</a:t>
+              <a:t>遨阪∩荳翫￡繝ｭ繧ｰ </a:t>
+            </a:r>
+            <a:r>
+              <a:rPr kumimoji="1" lang="en-US" altLang="zh-TW" sz="1600" b="1">
+                <a:solidFill>
+                  <a:srgbClr val="556F35"/>
+                </a:solidFill>
+                <a:latin typeface="Arial" panose="020B0604020202020204" pitchFamily="34" charset="0"/>
+              </a:rPr>
+              <a:t>/ </a:t>
+            </a:r>
+            <a:r>
+              <a:rPr kumimoji="1" lang="zh-TW" altLang="en-US" sz="1600" b="1">
+                <a:solidFill>
+                  <a:srgbClr val="556F35"/>
+                </a:solidFill>
+                <a:latin typeface="Arial" panose="020B0604020202020204" pitchFamily="34" charset="0"/>
+              </a:rPr>
+              <a:t>謚陦楢ｧ</a:t>
+            </a:r>
+            <a:r>
+              <a:rPr kumimoji="1" lang="en-US" altLang="zh-TW" sz="1600" b="1">
+                <a:solidFill>
+                  <a:srgbClr val="556F35"/>
+                </a:solidFill>
+                <a:latin typeface="Arial" panose="020B0604020202020204" pitchFamily="34" charset="0"/>
+              </a:rPr>
+              <a:t>｣</a:t>
+            </a:r>
+            <a:r>
+              <a:rPr kumimoji="1" lang="zh-TW" altLang="en-US" sz="1600" b="1">
+                <a:solidFill>
+                  <a:srgbClr val="556F35"/>
+                </a:solidFill>
+                <a:latin typeface="Arial" panose="020B0604020202020204" pitchFamily="34" charset="0"/>
+              </a:rPr>
+              <a:t>隱ｬ蜍慕判</a:t>
             </a:r>
             <a:endParaRPr kumimoji="1" lang="ja-JP" altLang="en-US" sz="1600" b="1">
               <a:solidFill>
@@ -5522,7 +5738,7 @@
           <p:cNvPr id="3" name="テキスト ボックス 2">
             <a:extLst>
               <a:ext uri="{FF2B5EF4-FFF2-40B4-BE49-F238E27FC236}">
-                <a16:creationId xmlns:a16="http://schemas.microsoft.com/office/drawing/2014/main" id="{099B54B5-8567-371D-EBFF-86EBCE3D9509}"/>
+                <a16:creationId xmlns:a16="http://schemas.microsoft.com/office/drawing/2014/main" id="{868B1C0D-4656-6F89-86E4-4F5CA9E30EA2}"/>
               </a:ext>
             </a:extLst>
           </p:cNvPr>
@@ -5562,7 +5778,7 @@
           <p:cNvPr id="4" name="テキスト ボックス 3">
             <a:extLst>
               <a:ext uri="{FF2B5EF4-FFF2-40B4-BE49-F238E27FC236}">
-                <a16:creationId xmlns:a16="http://schemas.microsoft.com/office/drawing/2014/main" id="{34F6E6C5-6DD1-D785-28D5-DA4B7C5B24FB}"/>
+                <a16:creationId xmlns:a16="http://schemas.microsoft.com/office/drawing/2014/main" id="{9652B779-9CB5-469B-A5DC-F3B855955CDB}"/>
               </a:ext>
             </a:extLst>
           </p:cNvPr>
@@ -5627,7 +5843,7 @@
           <p:cNvPr id="5" name="テキスト ボックス 4">
             <a:extLst>
               <a:ext uri="{FF2B5EF4-FFF2-40B4-BE49-F238E27FC236}">
-                <a16:creationId xmlns:a16="http://schemas.microsoft.com/office/drawing/2014/main" id="{C2C0305A-987A-154A-02CA-E48DEAA35108}"/>
+                <a16:creationId xmlns:a16="http://schemas.microsoft.com/office/drawing/2014/main" id="{D561D33C-3C33-CF88-9973-FDA00056383E}"/>
               </a:ext>
             </a:extLst>
           </p:cNvPr>
@@ -5674,7 +5890,7 @@
             <a:hlinkClick r:id="" action="ppaction://media"/>
             <a:extLst>
               <a:ext uri="{FF2B5EF4-FFF2-40B4-BE49-F238E27FC236}">
-                <a16:creationId xmlns:a16="http://schemas.microsoft.com/office/drawing/2014/main" id="{A0B30A57-3443-412F-6D87-B4641CCC0A26}"/>
+                <a16:creationId xmlns:a16="http://schemas.microsoft.com/office/drawing/2014/main" id="{76424C50-713A-9D4F-32FA-9410BE0CB55B}"/>
               </a:ext>
             </a:extLst>
           </p:cNvPr>
@@ -5709,7 +5925,7 @@
     </p:spTree>
     <p:extLst>
       <p:ext uri="{BB962C8B-B14F-4D97-AF65-F5344CB8AC3E}">
-        <p14:creationId xmlns:p14="http://schemas.microsoft.com/office/powerpoint/2010/main" val="3567737938"/>
+        <p14:creationId xmlns:p14="http://schemas.microsoft.com/office/powerpoint/2010/main" val="3975417554"/>
       </p:ext>
     </p:extLst>
   </p:cSld>

</xml_diff>

<commit_message>
Fix Japanese text in generated video
</commit_message>
<xml_diff>
--- a/video-assets/repositories/king-epark-neo/king-epark-neo-tech-preview.pptx
+++ b/video-assets/repositories/king-epark-neo/king-epark-neo-tech-preview.pptx
@@ -134,7 +134,7 @@
           <p:cNvPr id="2" name="タイトル 1">
             <a:extLst>
               <a:ext uri="{FF2B5EF4-FFF2-40B4-BE49-F238E27FC236}">
-                <a16:creationId xmlns:a16="http://schemas.microsoft.com/office/drawing/2014/main" id="{8BDBA2E4-31C0-7E28-2662-A20C0BCA83EC}"/>
+                <a16:creationId xmlns:a16="http://schemas.microsoft.com/office/drawing/2014/main" id="{0071D23F-B56E-8EB2-E23D-4EC2C11CAAFB}"/>
               </a:ext>
             </a:extLst>
           </p:cNvPr>
@@ -171,7 +171,7 @@
           <p:cNvPr id="3" name="字幕 2">
             <a:extLst>
               <a:ext uri="{FF2B5EF4-FFF2-40B4-BE49-F238E27FC236}">
-                <a16:creationId xmlns:a16="http://schemas.microsoft.com/office/drawing/2014/main" id="{338A680B-065F-1B07-0A42-EBF4E401C4B3}"/>
+                <a16:creationId xmlns:a16="http://schemas.microsoft.com/office/drawing/2014/main" id="{612690E8-D3FE-9C3D-EB85-8BB01241C322}"/>
               </a:ext>
             </a:extLst>
           </p:cNvPr>
@@ -241,7 +241,7 @@
           <p:cNvPr id="4" name="日付プレースホルダー 3">
             <a:extLst>
               <a:ext uri="{FF2B5EF4-FFF2-40B4-BE49-F238E27FC236}">
-                <a16:creationId xmlns:a16="http://schemas.microsoft.com/office/drawing/2014/main" id="{0CE4BE0D-734B-8882-BDCB-449212345804}"/>
+                <a16:creationId xmlns:a16="http://schemas.microsoft.com/office/drawing/2014/main" id="{DDA0EA4E-2E85-E5EE-10BE-5D97671D37BE}"/>
               </a:ext>
             </a:extLst>
           </p:cNvPr>
@@ -257,7 +257,7 @@
           <a:bodyPr/>
           <a:lstStyle/>
           <a:p>
-            <a:fld id="{4ABB2253-A87D-461A-BEF5-E9762CC1454B}" type="datetimeFigureOut">
+            <a:fld id="{E36B06F2-3DC0-4847-A1E4-4EFDA763A8E6}" type="datetimeFigureOut">
               <a:rPr kumimoji="1" lang="ja-JP" altLang="en-US" smtClean="0"/>
               <a:t>2026/8/2</a:t>
             </a:fld>
@@ -270,7 +270,7 @@
           <p:cNvPr id="5" name="フッター プレースホルダー 4">
             <a:extLst>
               <a:ext uri="{FF2B5EF4-FFF2-40B4-BE49-F238E27FC236}">
-                <a16:creationId xmlns:a16="http://schemas.microsoft.com/office/drawing/2014/main" id="{9E89F922-0E28-B924-2430-B148C9B5EAA9}"/>
+                <a16:creationId xmlns:a16="http://schemas.microsoft.com/office/drawing/2014/main" id="{28126D84-4273-3936-6454-D39D30A77216}"/>
               </a:ext>
             </a:extLst>
           </p:cNvPr>
@@ -295,7 +295,7 @@
           <p:cNvPr id="6" name="スライド番号プレースホルダー 5">
             <a:extLst>
               <a:ext uri="{FF2B5EF4-FFF2-40B4-BE49-F238E27FC236}">
-                <a16:creationId xmlns:a16="http://schemas.microsoft.com/office/drawing/2014/main" id="{F711F73D-AFC6-3AD4-E490-48AE6C56A6D8}"/>
+                <a16:creationId xmlns:a16="http://schemas.microsoft.com/office/drawing/2014/main" id="{B2F66AE3-0129-4CDB-66AA-F772DBCBEB45}"/>
               </a:ext>
             </a:extLst>
           </p:cNvPr>
@@ -311,7 +311,7 @@
           <a:bodyPr/>
           <a:lstStyle/>
           <a:p>
-            <a:fld id="{D559EA92-F8DF-420E-A5E8-4940031E9E8E}" type="slidenum">
+            <a:fld id="{358B2D0C-41AD-44D7-BAEA-F8F9A99E35C6}" type="slidenum">
               <a:rPr kumimoji="1" lang="ja-JP" altLang="en-US" smtClean="0"/>
               <a:t>‹#›</a:t>
             </a:fld>
@@ -322,7 +322,7 @@
     </p:spTree>
     <p:extLst>
       <p:ext uri="{BB962C8B-B14F-4D97-AF65-F5344CB8AC3E}">
-        <p14:creationId xmlns:p14="http://schemas.microsoft.com/office/powerpoint/2010/main" val="729007969"/>
+        <p14:creationId xmlns:p14="http://schemas.microsoft.com/office/powerpoint/2010/main" val="139505561"/>
       </p:ext>
     </p:extLst>
   </p:cSld>
@@ -354,7 +354,7 @@
           <p:cNvPr id="2" name="タイトル 1">
             <a:extLst>
               <a:ext uri="{FF2B5EF4-FFF2-40B4-BE49-F238E27FC236}">
-                <a16:creationId xmlns:a16="http://schemas.microsoft.com/office/drawing/2014/main" id="{5FBC8B20-A406-29CE-1389-CE38A03D10F0}"/>
+                <a16:creationId xmlns:a16="http://schemas.microsoft.com/office/drawing/2014/main" id="{62CAE3F2-7B65-6F59-D938-E133ED4A5452}"/>
               </a:ext>
             </a:extLst>
           </p:cNvPr>
@@ -382,7 +382,7 @@
           <p:cNvPr id="3" name="縦書きテキスト プレースホルダー 2">
             <a:extLst>
               <a:ext uri="{FF2B5EF4-FFF2-40B4-BE49-F238E27FC236}">
-                <a16:creationId xmlns:a16="http://schemas.microsoft.com/office/drawing/2014/main" id="{E115DECE-EADC-665A-A4A0-BBB2C4BC28DE}"/>
+                <a16:creationId xmlns:a16="http://schemas.microsoft.com/office/drawing/2014/main" id="{D9E8EAB0-CAB1-DC2D-F387-C4DC9B11D2C9}"/>
               </a:ext>
             </a:extLst>
           </p:cNvPr>
@@ -471,7 +471,7 @@
           <p:cNvPr id="4" name="日付プレースホルダー 3">
             <a:extLst>
               <a:ext uri="{FF2B5EF4-FFF2-40B4-BE49-F238E27FC236}">
-                <a16:creationId xmlns:a16="http://schemas.microsoft.com/office/drawing/2014/main" id="{113A0E91-0C99-6ABD-B0DA-46B479695813}"/>
+                <a16:creationId xmlns:a16="http://schemas.microsoft.com/office/drawing/2014/main" id="{E124DC46-DA31-CA74-417B-53191E25950B}"/>
               </a:ext>
             </a:extLst>
           </p:cNvPr>
@@ -487,7 +487,7 @@
           <a:bodyPr/>
           <a:lstStyle/>
           <a:p>
-            <a:fld id="{4ABB2253-A87D-461A-BEF5-E9762CC1454B}" type="datetimeFigureOut">
+            <a:fld id="{E36B06F2-3DC0-4847-A1E4-4EFDA763A8E6}" type="datetimeFigureOut">
               <a:rPr kumimoji="1" lang="ja-JP" altLang="en-US" smtClean="0"/>
               <a:t>2026/8/2</a:t>
             </a:fld>
@@ -500,7 +500,7 @@
           <p:cNvPr id="5" name="フッター プレースホルダー 4">
             <a:extLst>
               <a:ext uri="{FF2B5EF4-FFF2-40B4-BE49-F238E27FC236}">
-                <a16:creationId xmlns:a16="http://schemas.microsoft.com/office/drawing/2014/main" id="{9E9E8317-422D-FBD6-9EE7-3ED570A498F6}"/>
+                <a16:creationId xmlns:a16="http://schemas.microsoft.com/office/drawing/2014/main" id="{FC41CC77-2FAB-22AC-2709-D94E27C1C649}"/>
               </a:ext>
             </a:extLst>
           </p:cNvPr>
@@ -525,7 +525,7 @@
           <p:cNvPr id="6" name="スライド番号プレースホルダー 5">
             <a:extLst>
               <a:ext uri="{FF2B5EF4-FFF2-40B4-BE49-F238E27FC236}">
-                <a16:creationId xmlns:a16="http://schemas.microsoft.com/office/drawing/2014/main" id="{9709887D-8C8B-F370-0BB6-470C5D45EE64}"/>
+                <a16:creationId xmlns:a16="http://schemas.microsoft.com/office/drawing/2014/main" id="{17EF4DD4-7989-DD24-0D09-7B110564D6A4}"/>
               </a:ext>
             </a:extLst>
           </p:cNvPr>
@@ -541,7 +541,7 @@
           <a:bodyPr/>
           <a:lstStyle/>
           <a:p>
-            <a:fld id="{D559EA92-F8DF-420E-A5E8-4940031E9E8E}" type="slidenum">
+            <a:fld id="{358B2D0C-41AD-44D7-BAEA-F8F9A99E35C6}" type="slidenum">
               <a:rPr kumimoji="1" lang="ja-JP" altLang="en-US" smtClean="0"/>
               <a:t>‹#›</a:t>
             </a:fld>
@@ -552,7 +552,7 @@
     </p:spTree>
     <p:extLst>
       <p:ext uri="{BB962C8B-B14F-4D97-AF65-F5344CB8AC3E}">
-        <p14:creationId xmlns:p14="http://schemas.microsoft.com/office/powerpoint/2010/main" val="576623341"/>
+        <p14:creationId xmlns:p14="http://schemas.microsoft.com/office/powerpoint/2010/main" val="3035296094"/>
       </p:ext>
     </p:extLst>
   </p:cSld>
@@ -584,7 +584,7 @@
           <p:cNvPr id="2" name="縦書きタイトル 1">
             <a:extLst>
               <a:ext uri="{FF2B5EF4-FFF2-40B4-BE49-F238E27FC236}">
-                <a16:creationId xmlns:a16="http://schemas.microsoft.com/office/drawing/2014/main" id="{831A892A-9C8B-48D0-FC4C-E72AFCCF55D5}"/>
+                <a16:creationId xmlns:a16="http://schemas.microsoft.com/office/drawing/2014/main" id="{8D50F508-1B81-6A13-3537-BD4019172229}"/>
               </a:ext>
             </a:extLst>
           </p:cNvPr>
@@ -617,7 +617,7 @@
           <p:cNvPr id="3" name="縦書きテキスト プレースホルダー 2">
             <a:extLst>
               <a:ext uri="{FF2B5EF4-FFF2-40B4-BE49-F238E27FC236}">
-                <a16:creationId xmlns:a16="http://schemas.microsoft.com/office/drawing/2014/main" id="{0E350507-C213-224C-F9BA-4A596905F9B1}"/>
+                <a16:creationId xmlns:a16="http://schemas.microsoft.com/office/drawing/2014/main" id="{F8CA1BF5-8977-8A6C-8A0C-EE8EABAFE8FC}"/>
               </a:ext>
             </a:extLst>
           </p:cNvPr>
@@ -711,7 +711,7 @@
           <p:cNvPr id="4" name="日付プレースホルダー 3">
             <a:extLst>
               <a:ext uri="{FF2B5EF4-FFF2-40B4-BE49-F238E27FC236}">
-                <a16:creationId xmlns:a16="http://schemas.microsoft.com/office/drawing/2014/main" id="{15908E8A-73AC-786C-6057-5D26BC1D26EC}"/>
+                <a16:creationId xmlns:a16="http://schemas.microsoft.com/office/drawing/2014/main" id="{2050F1D7-F8E0-459D-88B2-8FCB76C22562}"/>
               </a:ext>
             </a:extLst>
           </p:cNvPr>
@@ -727,7 +727,7 @@
           <a:bodyPr/>
           <a:lstStyle/>
           <a:p>
-            <a:fld id="{4ABB2253-A87D-461A-BEF5-E9762CC1454B}" type="datetimeFigureOut">
+            <a:fld id="{E36B06F2-3DC0-4847-A1E4-4EFDA763A8E6}" type="datetimeFigureOut">
               <a:rPr kumimoji="1" lang="ja-JP" altLang="en-US" smtClean="0"/>
               <a:t>2026/8/2</a:t>
             </a:fld>
@@ -740,7 +740,7 @@
           <p:cNvPr id="5" name="フッター プレースホルダー 4">
             <a:extLst>
               <a:ext uri="{FF2B5EF4-FFF2-40B4-BE49-F238E27FC236}">
-                <a16:creationId xmlns:a16="http://schemas.microsoft.com/office/drawing/2014/main" id="{70B63605-D256-EE45-79A7-0F11E86820D8}"/>
+                <a16:creationId xmlns:a16="http://schemas.microsoft.com/office/drawing/2014/main" id="{D8F85BC2-5A9B-79AB-A37F-FAE979742F06}"/>
               </a:ext>
             </a:extLst>
           </p:cNvPr>
@@ -765,7 +765,7 @@
           <p:cNvPr id="6" name="スライド番号プレースホルダー 5">
             <a:extLst>
               <a:ext uri="{FF2B5EF4-FFF2-40B4-BE49-F238E27FC236}">
-                <a16:creationId xmlns:a16="http://schemas.microsoft.com/office/drawing/2014/main" id="{E9D79D58-01A5-DDE1-5163-E5AF01EE7B58}"/>
+                <a16:creationId xmlns:a16="http://schemas.microsoft.com/office/drawing/2014/main" id="{33DA36C2-7982-485F-A1D1-4B7E0FD244F4}"/>
               </a:ext>
             </a:extLst>
           </p:cNvPr>
@@ -781,7 +781,7 @@
           <a:bodyPr/>
           <a:lstStyle/>
           <a:p>
-            <a:fld id="{D559EA92-F8DF-420E-A5E8-4940031E9E8E}" type="slidenum">
+            <a:fld id="{358B2D0C-41AD-44D7-BAEA-F8F9A99E35C6}" type="slidenum">
               <a:rPr kumimoji="1" lang="ja-JP" altLang="en-US" smtClean="0"/>
               <a:t>‹#›</a:t>
             </a:fld>
@@ -792,7 +792,7 @@
     </p:spTree>
     <p:extLst>
       <p:ext uri="{BB962C8B-B14F-4D97-AF65-F5344CB8AC3E}">
-        <p14:creationId xmlns:p14="http://schemas.microsoft.com/office/powerpoint/2010/main" val="2036133662"/>
+        <p14:creationId xmlns:p14="http://schemas.microsoft.com/office/powerpoint/2010/main" val="1587207199"/>
       </p:ext>
     </p:extLst>
   </p:cSld>
@@ -824,7 +824,7 @@
           <p:cNvPr id="2" name="タイトル 1">
             <a:extLst>
               <a:ext uri="{FF2B5EF4-FFF2-40B4-BE49-F238E27FC236}">
-                <a16:creationId xmlns:a16="http://schemas.microsoft.com/office/drawing/2014/main" id="{FE9C163A-6D5E-E263-7F37-3E39E216C722}"/>
+                <a16:creationId xmlns:a16="http://schemas.microsoft.com/office/drawing/2014/main" id="{25AC782E-FDAD-B83F-BFA7-53548EDEF301}"/>
               </a:ext>
             </a:extLst>
           </p:cNvPr>
@@ -852,7 +852,7 @@
           <p:cNvPr id="3" name="コンテンツ プレースホルダー 2">
             <a:extLst>
               <a:ext uri="{FF2B5EF4-FFF2-40B4-BE49-F238E27FC236}">
-                <a16:creationId xmlns:a16="http://schemas.microsoft.com/office/drawing/2014/main" id="{C4955FDF-AFD2-935B-D2D0-DB598907412F}"/>
+                <a16:creationId xmlns:a16="http://schemas.microsoft.com/office/drawing/2014/main" id="{AA07D3F8-1AA6-D29D-60AB-130DEB7C7308}"/>
               </a:ext>
             </a:extLst>
           </p:cNvPr>
@@ -941,7 +941,7 @@
           <p:cNvPr id="4" name="日付プレースホルダー 3">
             <a:extLst>
               <a:ext uri="{FF2B5EF4-FFF2-40B4-BE49-F238E27FC236}">
-                <a16:creationId xmlns:a16="http://schemas.microsoft.com/office/drawing/2014/main" id="{A75548F1-D34B-9709-8B54-E2E7A840014C}"/>
+                <a16:creationId xmlns:a16="http://schemas.microsoft.com/office/drawing/2014/main" id="{FA63A7CC-11C2-04DA-7253-6DD635E911AE}"/>
               </a:ext>
             </a:extLst>
           </p:cNvPr>
@@ -957,7 +957,7 @@
           <a:bodyPr/>
           <a:lstStyle/>
           <a:p>
-            <a:fld id="{4ABB2253-A87D-461A-BEF5-E9762CC1454B}" type="datetimeFigureOut">
+            <a:fld id="{E36B06F2-3DC0-4847-A1E4-4EFDA763A8E6}" type="datetimeFigureOut">
               <a:rPr kumimoji="1" lang="ja-JP" altLang="en-US" smtClean="0"/>
               <a:t>2026/8/2</a:t>
             </a:fld>
@@ -970,7 +970,7 @@
           <p:cNvPr id="5" name="フッター プレースホルダー 4">
             <a:extLst>
               <a:ext uri="{FF2B5EF4-FFF2-40B4-BE49-F238E27FC236}">
-                <a16:creationId xmlns:a16="http://schemas.microsoft.com/office/drawing/2014/main" id="{B1DE4E9A-DF0C-8E1F-D942-F8806DDE5530}"/>
+                <a16:creationId xmlns:a16="http://schemas.microsoft.com/office/drawing/2014/main" id="{D0DB0E90-28E2-3D84-AA72-BAC02CDD8CED}"/>
               </a:ext>
             </a:extLst>
           </p:cNvPr>
@@ -995,7 +995,7 @@
           <p:cNvPr id="6" name="スライド番号プレースホルダー 5">
             <a:extLst>
               <a:ext uri="{FF2B5EF4-FFF2-40B4-BE49-F238E27FC236}">
-                <a16:creationId xmlns:a16="http://schemas.microsoft.com/office/drawing/2014/main" id="{0C49EB10-0EAB-FB5C-169B-28C20EBD4537}"/>
+                <a16:creationId xmlns:a16="http://schemas.microsoft.com/office/drawing/2014/main" id="{5911D3D0-4C1C-BB7F-6FFD-F7064A54CCDC}"/>
               </a:ext>
             </a:extLst>
           </p:cNvPr>
@@ -1011,7 +1011,7 @@
           <a:bodyPr/>
           <a:lstStyle/>
           <a:p>
-            <a:fld id="{D559EA92-F8DF-420E-A5E8-4940031E9E8E}" type="slidenum">
+            <a:fld id="{358B2D0C-41AD-44D7-BAEA-F8F9A99E35C6}" type="slidenum">
               <a:rPr kumimoji="1" lang="ja-JP" altLang="en-US" smtClean="0"/>
               <a:t>‹#›</a:t>
             </a:fld>
@@ -1022,7 +1022,7 @@
     </p:spTree>
     <p:extLst>
       <p:ext uri="{BB962C8B-B14F-4D97-AF65-F5344CB8AC3E}">
-        <p14:creationId xmlns:p14="http://schemas.microsoft.com/office/powerpoint/2010/main" val="2011285049"/>
+        <p14:creationId xmlns:p14="http://schemas.microsoft.com/office/powerpoint/2010/main" val="1498929354"/>
       </p:ext>
     </p:extLst>
   </p:cSld>
@@ -1054,7 +1054,7 @@
           <p:cNvPr id="2" name="タイトル 1">
             <a:extLst>
               <a:ext uri="{FF2B5EF4-FFF2-40B4-BE49-F238E27FC236}">
-                <a16:creationId xmlns:a16="http://schemas.microsoft.com/office/drawing/2014/main" id="{BA880D02-0B09-85D7-3434-66BB25CD049C}"/>
+                <a16:creationId xmlns:a16="http://schemas.microsoft.com/office/drawing/2014/main" id="{EB6D8879-C1E3-3FE0-6F45-B76102CB56D8}"/>
               </a:ext>
             </a:extLst>
           </p:cNvPr>
@@ -1091,7 +1091,7 @@
           <p:cNvPr id="3" name="テキスト プレースホルダー 2">
             <a:extLst>
               <a:ext uri="{FF2B5EF4-FFF2-40B4-BE49-F238E27FC236}">
-                <a16:creationId xmlns:a16="http://schemas.microsoft.com/office/drawing/2014/main" id="{BB7DDA32-16E0-042F-1BB5-35CECEB765CF}"/>
+                <a16:creationId xmlns:a16="http://schemas.microsoft.com/office/drawing/2014/main" id="{52219BB3-A024-07C4-DDB5-E42A6ABEE2EC}"/>
               </a:ext>
             </a:extLst>
           </p:cNvPr>
@@ -1216,7 +1216,7 @@
           <p:cNvPr id="4" name="日付プレースホルダー 3">
             <a:extLst>
               <a:ext uri="{FF2B5EF4-FFF2-40B4-BE49-F238E27FC236}">
-                <a16:creationId xmlns:a16="http://schemas.microsoft.com/office/drawing/2014/main" id="{42C20A3E-BBDD-BC20-EB01-8DE1AE92427D}"/>
+                <a16:creationId xmlns:a16="http://schemas.microsoft.com/office/drawing/2014/main" id="{605E8165-8711-A4CD-5312-D7F7A9D892A9}"/>
               </a:ext>
             </a:extLst>
           </p:cNvPr>
@@ -1232,7 +1232,7 @@
           <a:bodyPr/>
           <a:lstStyle/>
           <a:p>
-            <a:fld id="{4ABB2253-A87D-461A-BEF5-E9762CC1454B}" type="datetimeFigureOut">
+            <a:fld id="{E36B06F2-3DC0-4847-A1E4-4EFDA763A8E6}" type="datetimeFigureOut">
               <a:rPr kumimoji="1" lang="ja-JP" altLang="en-US" smtClean="0"/>
               <a:t>2026/8/2</a:t>
             </a:fld>
@@ -1245,7 +1245,7 @@
           <p:cNvPr id="5" name="フッター プレースホルダー 4">
             <a:extLst>
               <a:ext uri="{FF2B5EF4-FFF2-40B4-BE49-F238E27FC236}">
-                <a16:creationId xmlns:a16="http://schemas.microsoft.com/office/drawing/2014/main" id="{3D9E35A1-8626-BF25-34A3-50B63C0FC038}"/>
+                <a16:creationId xmlns:a16="http://schemas.microsoft.com/office/drawing/2014/main" id="{D8AC0C17-2AB6-5A74-3E29-819C5BA35C71}"/>
               </a:ext>
             </a:extLst>
           </p:cNvPr>
@@ -1270,7 +1270,7 @@
           <p:cNvPr id="6" name="スライド番号プレースホルダー 5">
             <a:extLst>
               <a:ext uri="{FF2B5EF4-FFF2-40B4-BE49-F238E27FC236}">
-                <a16:creationId xmlns:a16="http://schemas.microsoft.com/office/drawing/2014/main" id="{5C919555-9243-A860-3FA0-B78FE1C30739}"/>
+                <a16:creationId xmlns:a16="http://schemas.microsoft.com/office/drawing/2014/main" id="{60633F11-2C14-1BA5-A786-AB5561339C03}"/>
               </a:ext>
             </a:extLst>
           </p:cNvPr>
@@ -1286,7 +1286,7 @@
           <a:bodyPr/>
           <a:lstStyle/>
           <a:p>
-            <a:fld id="{D559EA92-F8DF-420E-A5E8-4940031E9E8E}" type="slidenum">
+            <a:fld id="{358B2D0C-41AD-44D7-BAEA-F8F9A99E35C6}" type="slidenum">
               <a:rPr kumimoji="1" lang="ja-JP" altLang="en-US" smtClean="0"/>
               <a:t>‹#›</a:t>
             </a:fld>
@@ -1297,7 +1297,7 @@
     </p:spTree>
     <p:extLst>
       <p:ext uri="{BB962C8B-B14F-4D97-AF65-F5344CB8AC3E}">
-        <p14:creationId xmlns:p14="http://schemas.microsoft.com/office/powerpoint/2010/main" val="4210148107"/>
+        <p14:creationId xmlns:p14="http://schemas.microsoft.com/office/powerpoint/2010/main" val="203712567"/>
       </p:ext>
     </p:extLst>
   </p:cSld>
@@ -1329,7 +1329,7 @@
           <p:cNvPr id="2" name="タイトル 1">
             <a:extLst>
               <a:ext uri="{FF2B5EF4-FFF2-40B4-BE49-F238E27FC236}">
-                <a16:creationId xmlns:a16="http://schemas.microsoft.com/office/drawing/2014/main" id="{9288F5E5-496E-D8EE-5966-9B1B6D1DAFBD}"/>
+                <a16:creationId xmlns:a16="http://schemas.microsoft.com/office/drawing/2014/main" id="{E6D2174C-D62B-5CBD-D6B8-107C65079E5F}"/>
               </a:ext>
             </a:extLst>
           </p:cNvPr>
@@ -1357,7 +1357,7 @@
           <p:cNvPr id="3" name="コンテンツ プレースホルダー 2">
             <a:extLst>
               <a:ext uri="{FF2B5EF4-FFF2-40B4-BE49-F238E27FC236}">
-                <a16:creationId xmlns:a16="http://schemas.microsoft.com/office/drawing/2014/main" id="{51B5281D-F7D7-7D6E-2A93-EBCC09D3ADCD}"/>
+                <a16:creationId xmlns:a16="http://schemas.microsoft.com/office/drawing/2014/main" id="{17071B20-AEC2-84D2-A8BB-B506BDE23CFB}"/>
               </a:ext>
             </a:extLst>
           </p:cNvPr>
@@ -1451,7 +1451,7 @@
           <p:cNvPr id="4" name="コンテンツ プレースホルダー 3">
             <a:extLst>
               <a:ext uri="{FF2B5EF4-FFF2-40B4-BE49-F238E27FC236}">
-                <a16:creationId xmlns:a16="http://schemas.microsoft.com/office/drawing/2014/main" id="{E9C5CD86-3E46-DDF3-C844-07D3B090C928}"/>
+                <a16:creationId xmlns:a16="http://schemas.microsoft.com/office/drawing/2014/main" id="{8EAA1704-039B-FD9B-98CB-B4D069B589BD}"/>
               </a:ext>
             </a:extLst>
           </p:cNvPr>
@@ -1545,7 +1545,7 @@
           <p:cNvPr id="5" name="日付プレースホルダー 4">
             <a:extLst>
               <a:ext uri="{FF2B5EF4-FFF2-40B4-BE49-F238E27FC236}">
-                <a16:creationId xmlns:a16="http://schemas.microsoft.com/office/drawing/2014/main" id="{6AD812C7-B539-F812-63FA-41E31B5A14B5}"/>
+                <a16:creationId xmlns:a16="http://schemas.microsoft.com/office/drawing/2014/main" id="{05224002-537A-E6C6-979C-D74C70FFBF11}"/>
               </a:ext>
             </a:extLst>
           </p:cNvPr>
@@ -1561,7 +1561,7 @@
           <a:bodyPr/>
           <a:lstStyle/>
           <a:p>
-            <a:fld id="{4ABB2253-A87D-461A-BEF5-E9762CC1454B}" type="datetimeFigureOut">
+            <a:fld id="{E36B06F2-3DC0-4847-A1E4-4EFDA763A8E6}" type="datetimeFigureOut">
               <a:rPr kumimoji="1" lang="ja-JP" altLang="en-US" smtClean="0"/>
               <a:t>2026/8/2</a:t>
             </a:fld>
@@ -1574,7 +1574,7 @@
           <p:cNvPr id="6" name="フッター プレースホルダー 5">
             <a:extLst>
               <a:ext uri="{FF2B5EF4-FFF2-40B4-BE49-F238E27FC236}">
-                <a16:creationId xmlns:a16="http://schemas.microsoft.com/office/drawing/2014/main" id="{A8775ABD-CDB6-0868-D03C-CD6D848FE543}"/>
+                <a16:creationId xmlns:a16="http://schemas.microsoft.com/office/drawing/2014/main" id="{4C29D941-67D1-1F88-2140-191A431B233F}"/>
               </a:ext>
             </a:extLst>
           </p:cNvPr>
@@ -1599,7 +1599,7 @@
           <p:cNvPr id="7" name="スライド番号プレースホルダー 6">
             <a:extLst>
               <a:ext uri="{FF2B5EF4-FFF2-40B4-BE49-F238E27FC236}">
-                <a16:creationId xmlns:a16="http://schemas.microsoft.com/office/drawing/2014/main" id="{E08ECB5B-F058-9D24-6C76-10021B963B61}"/>
+                <a16:creationId xmlns:a16="http://schemas.microsoft.com/office/drawing/2014/main" id="{46C072AF-D742-B494-0B17-FEB7A6E92028}"/>
               </a:ext>
             </a:extLst>
           </p:cNvPr>
@@ -1615,7 +1615,7 @@
           <a:bodyPr/>
           <a:lstStyle/>
           <a:p>
-            <a:fld id="{D559EA92-F8DF-420E-A5E8-4940031E9E8E}" type="slidenum">
+            <a:fld id="{358B2D0C-41AD-44D7-BAEA-F8F9A99E35C6}" type="slidenum">
               <a:rPr kumimoji="1" lang="ja-JP" altLang="en-US" smtClean="0"/>
               <a:t>‹#›</a:t>
             </a:fld>
@@ -1626,7 +1626,7 @@
     </p:spTree>
     <p:extLst>
       <p:ext uri="{BB962C8B-B14F-4D97-AF65-F5344CB8AC3E}">
-        <p14:creationId xmlns:p14="http://schemas.microsoft.com/office/powerpoint/2010/main" val="2631125886"/>
+        <p14:creationId xmlns:p14="http://schemas.microsoft.com/office/powerpoint/2010/main" val="1158835082"/>
       </p:ext>
     </p:extLst>
   </p:cSld>
@@ -1658,7 +1658,7 @@
           <p:cNvPr id="2" name="タイトル 1">
             <a:extLst>
               <a:ext uri="{FF2B5EF4-FFF2-40B4-BE49-F238E27FC236}">
-                <a16:creationId xmlns:a16="http://schemas.microsoft.com/office/drawing/2014/main" id="{90675ED3-9248-FA9E-71A0-81590E1C6745}"/>
+                <a16:creationId xmlns:a16="http://schemas.microsoft.com/office/drawing/2014/main" id="{7F8D086A-D395-14EB-A5C8-DE05D9D225A3}"/>
               </a:ext>
             </a:extLst>
           </p:cNvPr>
@@ -1691,7 +1691,7 @@
           <p:cNvPr id="3" name="テキスト プレースホルダー 2">
             <a:extLst>
               <a:ext uri="{FF2B5EF4-FFF2-40B4-BE49-F238E27FC236}">
-                <a16:creationId xmlns:a16="http://schemas.microsoft.com/office/drawing/2014/main" id="{00A08534-4260-5502-BA2D-27FF662E3887}"/>
+                <a16:creationId xmlns:a16="http://schemas.microsoft.com/office/drawing/2014/main" id="{6E2F3010-AF88-6113-E0D0-18570F955BE8}"/>
               </a:ext>
             </a:extLst>
           </p:cNvPr>
@@ -1762,7 +1762,7 @@
           <p:cNvPr id="4" name="コンテンツ プレースホルダー 3">
             <a:extLst>
               <a:ext uri="{FF2B5EF4-FFF2-40B4-BE49-F238E27FC236}">
-                <a16:creationId xmlns:a16="http://schemas.microsoft.com/office/drawing/2014/main" id="{E9EDE405-3729-F328-6C06-2F35DABEAEF4}"/>
+                <a16:creationId xmlns:a16="http://schemas.microsoft.com/office/drawing/2014/main" id="{D18B37AA-1D06-0F77-ABAA-7FA0A9740339}"/>
               </a:ext>
             </a:extLst>
           </p:cNvPr>
@@ -1856,7 +1856,7 @@
           <p:cNvPr id="5" name="テキスト プレースホルダー 4">
             <a:extLst>
               <a:ext uri="{FF2B5EF4-FFF2-40B4-BE49-F238E27FC236}">
-                <a16:creationId xmlns:a16="http://schemas.microsoft.com/office/drawing/2014/main" id="{0225D2C6-7945-BD2D-02D5-7C1AA55A091F}"/>
+                <a16:creationId xmlns:a16="http://schemas.microsoft.com/office/drawing/2014/main" id="{55B883EC-4447-3493-6C59-AE9DA6CCD6EF}"/>
               </a:ext>
             </a:extLst>
           </p:cNvPr>
@@ -1927,7 +1927,7 @@
           <p:cNvPr id="6" name="コンテンツ プレースホルダー 5">
             <a:extLst>
               <a:ext uri="{FF2B5EF4-FFF2-40B4-BE49-F238E27FC236}">
-                <a16:creationId xmlns:a16="http://schemas.microsoft.com/office/drawing/2014/main" id="{0A3E2417-E543-5F3D-C3AF-14D58F5AF4E3}"/>
+                <a16:creationId xmlns:a16="http://schemas.microsoft.com/office/drawing/2014/main" id="{AC2A2FC4-42C4-4ADA-C89E-C6F17B2F4940}"/>
               </a:ext>
             </a:extLst>
           </p:cNvPr>
@@ -2021,7 +2021,7 @@
           <p:cNvPr id="7" name="日付プレースホルダー 6">
             <a:extLst>
               <a:ext uri="{FF2B5EF4-FFF2-40B4-BE49-F238E27FC236}">
-                <a16:creationId xmlns:a16="http://schemas.microsoft.com/office/drawing/2014/main" id="{01B70CB7-ADCF-ED20-127A-9162C978E181}"/>
+                <a16:creationId xmlns:a16="http://schemas.microsoft.com/office/drawing/2014/main" id="{0180F8F9-EDC8-D85F-4E2A-48A9EBBB8398}"/>
               </a:ext>
             </a:extLst>
           </p:cNvPr>
@@ -2037,7 +2037,7 @@
           <a:bodyPr/>
           <a:lstStyle/>
           <a:p>
-            <a:fld id="{4ABB2253-A87D-461A-BEF5-E9762CC1454B}" type="datetimeFigureOut">
+            <a:fld id="{E36B06F2-3DC0-4847-A1E4-4EFDA763A8E6}" type="datetimeFigureOut">
               <a:rPr kumimoji="1" lang="ja-JP" altLang="en-US" smtClean="0"/>
               <a:t>2026/8/2</a:t>
             </a:fld>
@@ -2050,7 +2050,7 @@
           <p:cNvPr id="8" name="フッター プレースホルダー 7">
             <a:extLst>
               <a:ext uri="{FF2B5EF4-FFF2-40B4-BE49-F238E27FC236}">
-                <a16:creationId xmlns:a16="http://schemas.microsoft.com/office/drawing/2014/main" id="{C53C9E8B-FAA7-7655-A4CD-9DEB9E132D72}"/>
+                <a16:creationId xmlns:a16="http://schemas.microsoft.com/office/drawing/2014/main" id="{DE758D80-79AF-68A3-15DC-E23FE2B78B6F}"/>
               </a:ext>
             </a:extLst>
           </p:cNvPr>
@@ -2075,7 +2075,7 @@
           <p:cNvPr id="9" name="スライド番号プレースホルダー 8">
             <a:extLst>
               <a:ext uri="{FF2B5EF4-FFF2-40B4-BE49-F238E27FC236}">
-                <a16:creationId xmlns:a16="http://schemas.microsoft.com/office/drawing/2014/main" id="{53622F84-EC92-AE81-BB00-67054CE0BFFB}"/>
+                <a16:creationId xmlns:a16="http://schemas.microsoft.com/office/drawing/2014/main" id="{208CB11B-5C26-9463-63BA-92EA1FF051DF}"/>
               </a:ext>
             </a:extLst>
           </p:cNvPr>
@@ -2091,7 +2091,7 @@
           <a:bodyPr/>
           <a:lstStyle/>
           <a:p>
-            <a:fld id="{D559EA92-F8DF-420E-A5E8-4940031E9E8E}" type="slidenum">
+            <a:fld id="{358B2D0C-41AD-44D7-BAEA-F8F9A99E35C6}" type="slidenum">
               <a:rPr kumimoji="1" lang="ja-JP" altLang="en-US" smtClean="0"/>
               <a:t>‹#›</a:t>
             </a:fld>
@@ -2102,7 +2102,7 @@
     </p:spTree>
     <p:extLst>
       <p:ext uri="{BB962C8B-B14F-4D97-AF65-F5344CB8AC3E}">
-        <p14:creationId xmlns:p14="http://schemas.microsoft.com/office/powerpoint/2010/main" val="3768279822"/>
+        <p14:creationId xmlns:p14="http://schemas.microsoft.com/office/powerpoint/2010/main" val="3275416625"/>
       </p:ext>
     </p:extLst>
   </p:cSld>
@@ -2134,7 +2134,7 @@
           <p:cNvPr id="2" name="タイトル 1">
             <a:extLst>
               <a:ext uri="{FF2B5EF4-FFF2-40B4-BE49-F238E27FC236}">
-                <a16:creationId xmlns:a16="http://schemas.microsoft.com/office/drawing/2014/main" id="{EDDB8368-1783-6F2D-87AE-BF69DBE33908}"/>
+                <a16:creationId xmlns:a16="http://schemas.microsoft.com/office/drawing/2014/main" id="{8A8DA29A-1C27-EB1D-1001-1596DD6B5A1D}"/>
               </a:ext>
             </a:extLst>
           </p:cNvPr>
@@ -2162,7 +2162,7 @@
           <p:cNvPr id="3" name="日付プレースホルダー 2">
             <a:extLst>
               <a:ext uri="{FF2B5EF4-FFF2-40B4-BE49-F238E27FC236}">
-                <a16:creationId xmlns:a16="http://schemas.microsoft.com/office/drawing/2014/main" id="{9A8CECDE-E6C6-38B5-2FA6-40C37D775A9F}"/>
+                <a16:creationId xmlns:a16="http://schemas.microsoft.com/office/drawing/2014/main" id="{C917DAF2-3AC7-EEC9-3327-A8C4CAB89811}"/>
               </a:ext>
             </a:extLst>
           </p:cNvPr>
@@ -2178,7 +2178,7 @@
           <a:bodyPr/>
           <a:lstStyle/>
           <a:p>
-            <a:fld id="{4ABB2253-A87D-461A-BEF5-E9762CC1454B}" type="datetimeFigureOut">
+            <a:fld id="{E36B06F2-3DC0-4847-A1E4-4EFDA763A8E6}" type="datetimeFigureOut">
               <a:rPr kumimoji="1" lang="ja-JP" altLang="en-US" smtClean="0"/>
               <a:t>2026/8/2</a:t>
             </a:fld>
@@ -2191,7 +2191,7 @@
           <p:cNvPr id="4" name="フッター プレースホルダー 3">
             <a:extLst>
               <a:ext uri="{FF2B5EF4-FFF2-40B4-BE49-F238E27FC236}">
-                <a16:creationId xmlns:a16="http://schemas.microsoft.com/office/drawing/2014/main" id="{1516272B-EDA1-40CE-4DD8-4F420CC01B0B}"/>
+                <a16:creationId xmlns:a16="http://schemas.microsoft.com/office/drawing/2014/main" id="{1A05E4F9-4FE8-AE76-1FDB-0B41A8218F3A}"/>
               </a:ext>
             </a:extLst>
           </p:cNvPr>
@@ -2216,7 +2216,7 @@
           <p:cNvPr id="5" name="スライド番号プレースホルダー 4">
             <a:extLst>
               <a:ext uri="{FF2B5EF4-FFF2-40B4-BE49-F238E27FC236}">
-                <a16:creationId xmlns:a16="http://schemas.microsoft.com/office/drawing/2014/main" id="{5D5FEC89-FA10-2ACD-2409-B32822E7810B}"/>
+                <a16:creationId xmlns:a16="http://schemas.microsoft.com/office/drawing/2014/main" id="{066530AF-B84B-C539-1B0A-CE8938A72230}"/>
               </a:ext>
             </a:extLst>
           </p:cNvPr>
@@ -2232,7 +2232,7 @@
           <a:bodyPr/>
           <a:lstStyle/>
           <a:p>
-            <a:fld id="{D559EA92-F8DF-420E-A5E8-4940031E9E8E}" type="slidenum">
+            <a:fld id="{358B2D0C-41AD-44D7-BAEA-F8F9A99E35C6}" type="slidenum">
               <a:rPr kumimoji="1" lang="ja-JP" altLang="en-US" smtClean="0"/>
               <a:t>‹#›</a:t>
             </a:fld>
@@ -2243,7 +2243,7 @@
     </p:spTree>
     <p:extLst>
       <p:ext uri="{BB962C8B-B14F-4D97-AF65-F5344CB8AC3E}">
-        <p14:creationId xmlns:p14="http://schemas.microsoft.com/office/powerpoint/2010/main" val="4277798965"/>
+        <p14:creationId xmlns:p14="http://schemas.microsoft.com/office/powerpoint/2010/main" val="394790862"/>
       </p:ext>
     </p:extLst>
   </p:cSld>
@@ -2275,7 +2275,7 @@
           <p:cNvPr id="2" name="日付プレースホルダー 1">
             <a:extLst>
               <a:ext uri="{FF2B5EF4-FFF2-40B4-BE49-F238E27FC236}">
-                <a16:creationId xmlns:a16="http://schemas.microsoft.com/office/drawing/2014/main" id="{4CFF033D-5D93-CBFB-9703-F709BCD753E4}"/>
+                <a16:creationId xmlns:a16="http://schemas.microsoft.com/office/drawing/2014/main" id="{2A94BA68-CAE8-047C-1D26-E9F331A0D18A}"/>
               </a:ext>
             </a:extLst>
           </p:cNvPr>
@@ -2291,7 +2291,7 @@
           <a:bodyPr/>
           <a:lstStyle/>
           <a:p>
-            <a:fld id="{4ABB2253-A87D-461A-BEF5-E9762CC1454B}" type="datetimeFigureOut">
+            <a:fld id="{E36B06F2-3DC0-4847-A1E4-4EFDA763A8E6}" type="datetimeFigureOut">
               <a:rPr kumimoji="1" lang="ja-JP" altLang="en-US" smtClean="0"/>
               <a:t>2026/8/2</a:t>
             </a:fld>
@@ -2304,7 +2304,7 @@
           <p:cNvPr id="3" name="フッター プレースホルダー 2">
             <a:extLst>
               <a:ext uri="{FF2B5EF4-FFF2-40B4-BE49-F238E27FC236}">
-                <a16:creationId xmlns:a16="http://schemas.microsoft.com/office/drawing/2014/main" id="{4E794E52-8401-559B-46A5-DBBF2B22B653}"/>
+                <a16:creationId xmlns:a16="http://schemas.microsoft.com/office/drawing/2014/main" id="{7D9398A9-32D9-E723-A8B9-B6395E556EB7}"/>
               </a:ext>
             </a:extLst>
           </p:cNvPr>
@@ -2329,7 +2329,7 @@
           <p:cNvPr id="4" name="スライド番号プレースホルダー 3">
             <a:extLst>
               <a:ext uri="{FF2B5EF4-FFF2-40B4-BE49-F238E27FC236}">
-                <a16:creationId xmlns:a16="http://schemas.microsoft.com/office/drawing/2014/main" id="{2A3EE898-3207-5E54-4FAC-CFD2E9FBC87C}"/>
+                <a16:creationId xmlns:a16="http://schemas.microsoft.com/office/drawing/2014/main" id="{AB3D917D-7476-D526-AEF7-5D7A575EE01C}"/>
               </a:ext>
             </a:extLst>
           </p:cNvPr>
@@ -2345,7 +2345,7 @@
           <a:bodyPr/>
           <a:lstStyle/>
           <a:p>
-            <a:fld id="{D559EA92-F8DF-420E-A5E8-4940031E9E8E}" type="slidenum">
+            <a:fld id="{358B2D0C-41AD-44D7-BAEA-F8F9A99E35C6}" type="slidenum">
               <a:rPr kumimoji="1" lang="ja-JP" altLang="en-US" smtClean="0"/>
               <a:t>‹#›</a:t>
             </a:fld>
@@ -2356,7 +2356,7 @@
     </p:spTree>
     <p:extLst>
       <p:ext uri="{BB962C8B-B14F-4D97-AF65-F5344CB8AC3E}">
-        <p14:creationId xmlns:p14="http://schemas.microsoft.com/office/powerpoint/2010/main" val="1868946559"/>
+        <p14:creationId xmlns:p14="http://schemas.microsoft.com/office/powerpoint/2010/main" val="2409956645"/>
       </p:ext>
     </p:extLst>
   </p:cSld>
@@ -2388,7 +2388,7 @@
           <p:cNvPr id="2" name="タイトル 1">
             <a:extLst>
               <a:ext uri="{FF2B5EF4-FFF2-40B4-BE49-F238E27FC236}">
-                <a16:creationId xmlns:a16="http://schemas.microsoft.com/office/drawing/2014/main" id="{6BCBB5BD-3658-AFD9-36BA-A29180117149}"/>
+                <a16:creationId xmlns:a16="http://schemas.microsoft.com/office/drawing/2014/main" id="{E9E60E51-E9F6-6BDB-37F3-B94E234937F5}"/>
               </a:ext>
             </a:extLst>
           </p:cNvPr>
@@ -2425,7 +2425,7 @@
           <p:cNvPr id="3" name="コンテンツ プレースホルダー 2">
             <a:extLst>
               <a:ext uri="{FF2B5EF4-FFF2-40B4-BE49-F238E27FC236}">
-                <a16:creationId xmlns:a16="http://schemas.microsoft.com/office/drawing/2014/main" id="{C8C10C73-8F38-0E27-5FD7-4D749394BF76}"/>
+                <a16:creationId xmlns:a16="http://schemas.microsoft.com/office/drawing/2014/main" id="{6F6EC997-AC44-37C7-9AD5-02ABB7CB349E}"/>
               </a:ext>
             </a:extLst>
           </p:cNvPr>
@@ -2547,7 +2547,7 @@
           <p:cNvPr id="4" name="テキスト プレースホルダー 3">
             <a:extLst>
               <a:ext uri="{FF2B5EF4-FFF2-40B4-BE49-F238E27FC236}">
-                <a16:creationId xmlns:a16="http://schemas.microsoft.com/office/drawing/2014/main" id="{F48234DF-4BDB-67F3-6AA3-4416EDB1B73A}"/>
+                <a16:creationId xmlns:a16="http://schemas.microsoft.com/office/drawing/2014/main" id="{FA874695-2436-C270-372B-68DDA0E420E2}"/>
               </a:ext>
             </a:extLst>
           </p:cNvPr>
@@ -2618,7 +2618,7 @@
           <p:cNvPr id="5" name="日付プレースホルダー 4">
             <a:extLst>
               <a:ext uri="{FF2B5EF4-FFF2-40B4-BE49-F238E27FC236}">
-                <a16:creationId xmlns:a16="http://schemas.microsoft.com/office/drawing/2014/main" id="{A5FC5228-1BBF-B8E2-6E09-3C8814D967D1}"/>
+                <a16:creationId xmlns:a16="http://schemas.microsoft.com/office/drawing/2014/main" id="{4342F5BC-B38E-99BC-13EF-761EAF120772}"/>
               </a:ext>
             </a:extLst>
           </p:cNvPr>
@@ -2634,7 +2634,7 @@
           <a:bodyPr/>
           <a:lstStyle/>
           <a:p>
-            <a:fld id="{4ABB2253-A87D-461A-BEF5-E9762CC1454B}" type="datetimeFigureOut">
+            <a:fld id="{E36B06F2-3DC0-4847-A1E4-4EFDA763A8E6}" type="datetimeFigureOut">
               <a:rPr kumimoji="1" lang="ja-JP" altLang="en-US" smtClean="0"/>
               <a:t>2026/8/2</a:t>
             </a:fld>
@@ -2647,7 +2647,7 @@
           <p:cNvPr id="6" name="フッター プレースホルダー 5">
             <a:extLst>
               <a:ext uri="{FF2B5EF4-FFF2-40B4-BE49-F238E27FC236}">
-                <a16:creationId xmlns:a16="http://schemas.microsoft.com/office/drawing/2014/main" id="{2684915F-702F-B894-3719-BF551962E81D}"/>
+                <a16:creationId xmlns:a16="http://schemas.microsoft.com/office/drawing/2014/main" id="{94A821F1-C2CA-65E5-84C1-C528D5158DF3}"/>
               </a:ext>
             </a:extLst>
           </p:cNvPr>
@@ -2672,7 +2672,7 @@
           <p:cNvPr id="7" name="スライド番号プレースホルダー 6">
             <a:extLst>
               <a:ext uri="{FF2B5EF4-FFF2-40B4-BE49-F238E27FC236}">
-                <a16:creationId xmlns:a16="http://schemas.microsoft.com/office/drawing/2014/main" id="{F1CD23BF-E709-6536-D9E7-DA3DD909F2D1}"/>
+                <a16:creationId xmlns:a16="http://schemas.microsoft.com/office/drawing/2014/main" id="{F4B087EE-4F00-DDB3-0B23-95F9C9DABA32}"/>
               </a:ext>
             </a:extLst>
           </p:cNvPr>
@@ -2688,7 +2688,7 @@
           <a:bodyPr/>
           <a:lstStyle/>
           <a:p>
-            <a:fld id="{D559EA92-F8DF-420E-A5E8-4940031E9E8E}" type="slidenum">
+            <a:fld id="{358B2D0C-41AD-44D7-BAEA-F8F9A99E35C6}" type="slidenum">
               <a:rPr kumimoji="1" lang="ja-JP" altLang="en-US" smtClean="0"/>
               <a:t>‹#›</a:t>
             </a:fld>
@@ -2699,7 +2699,7 @@
     </p:spTree>
     <p:extLst>
       <p:ext uri="{BB962C8B-B14F-4D97-AF65-F5344CB8AC3E}">
-        <p14:creationId xmlns:p14="http://schemas.microsoft.com/office/powerpoint/2010/main" val="1391718478"/>
+        <p14:creationId xmlns:p14="http://schemas.microsoft.com/office/powerpoint/2010/main" val="2642431905"/>
       </p:ext>
     </p:extLst>
   </p:cSld>
@@ -2731,7 +2731,7 @@
           <p:cNvPr id="2" name="タイトル 1">
             <a:extLst>
               <a:ext uri="{FF2B5EF4-FFF2-40B4-BE49-F238E27FC236}">
-                <a16:creationId xmlns:a16="http://schemas.microsoft.com/office/drawing/2014/main" id="{B92A9F7A-F853-880B-8377-8E61B22F400E}"/>
+                <a16:creationId xmlns:a16="http://schemas.microsoft.com/office/drawing/2014/main" id="{7D13CAFE-198A-68A2-8331-71499DFCCE0C}"/>
               </a:ext>
             </a:extLst>
           </p:cNvPr>
@@ -2768,7 +2768,7 @@
           <p:cNvPr id="3" name="図プレースホルダー 2">
             <a:extLst>
               <a:ext uri="{FF2B5EF4-FFF2-40B4-BE49-F238E27FC236}">
-                <a16:creationId xmlns:a16="http://schemas.microsoft.com/office/drawing/2014/main" id="{1DC7D327-A3DC-53E0-558B-D9650408CEA1}"/>
+                <a16:creationId xmlns:a16="http://schemas.microsoft.com/office/drawing/2014/main" id="{335DEA57-C4B4-8BD6-92C1-55E65F330422}"/>
               </a:ext>
             </a:extLst>
           </p:cNvPr>
@@ -2835,7 +2835,7 @@
           <p:cNvPr id="4" name="テキスト プレースホルダー 3">
             <a:extLst>
               <a:ext uri="{FF2B5EF4-FFF2-40B4-BE49-F238E27FC236}">
-                <a16:creationId xmlns:a16="http://schemas.microsoft.com/office/drawing/2014/main" id="{D6934B15-8F0D-48FE-D3E6-A4967B9E4050}"/>
+                <a16:creationId xmlns:a16="http://schemas.microsoft.com/office/drawing/2014/main" id="{CE1D980E-0428-9A86-AB43-37279A3E4475}"/>
               </a:ext>
             </a:extLst>
           </p:cNvPr>
@@ -2906,7 +2906,7 @@
           <p:cNvPr id="5" name="日付プレースホルダー 4">
             <a:extLst>
               <a:ext uri="{FF2B5EF4-FFF2-40B4-BE49-F238E27FC236}">
-                <a16:creationId xmlns:a16="http://schemas.microsoft.com/office/drawing/2014/main" id="{ECEF8B99-8BC1-E55C-2BBC-AE6597E5FCD0}"/>
+                <a16:creationId xmlns:a16="http://schemas.microsoft.com/office/drawing/2014/main" id="{6FB83EF1-0AD7-E009-0A4D-3E7F3863B1A5}"/>
               </a:ext>
             </a:extLst>
           </p:cNvPr>
@@ -2922,7 +2922,7 @@
           <a:bodyPr/>
           <a:lstStyle/>
           <a:p>
-            <a:fld id="{4ABB2253-A87D-461A-BEF5-E9762CC1454B}" type="datetimeFigureOut">
+            <a:fld id="{E36B06F2-3DC0-4847-A1E4-4EFDA763A8E6}" type="datetimeFigureOut">
               <a:rPr kumimoji="1" lang="ja-JP" altLang="en-US" smtClean="0"/>
               <a:t>2026/8/2</a:t>
             </a:fld>
@@ -2935,7 +2935,7 @@
           <p:cNvPr id="6" name="フッター プレースホルダー 5">
             <a:extLst>
               <a:ext uri="{FF2B5EF4-FFF2-40B4-BE49-F238E27FC236}">
-                <a16:creationId xmlns:a16="http://schemas.microsoft.com/office/drawing/2014/main" id="{A5D88A2B-A573-6033-C8E0-22BD2FC4C07E}"/>
+                <a16:creationId xmlns:a16="http://schemas.microsoft.com/office/drawing/2014/main" id="{2DCB0A0B-89D0-249B-1283-DC715DE14EEB}"/>
               </a:ext>
             </a:extLst>
           </p:cNvPr>
@@ -2960,7 +2960,7 @@
           <p:cNvPr id="7" name="スライド番号プレースホルダー 6">
             <a:extLst>
               <a:ext uri="{FF2B5EF4-FFF2-40B4-BE49-F238E27FC236}">
-                <a16:creationId xmlns:a16="http://schemas.microsoft.com/office/drawing/2014/main" id="{036F3ABF-F443-7690-4306-EE52DA13F493}"/>
+                <a16:creationId xmlns:a16="http://schemas.microsoft.com/office/drawing/2014/main" id="{4DF6C1FA-80B5-D2C1-87E1-C02DAE811D0C}"/>
               </a:ext>
             </a:extLst>
           </p:cNvPr>
@@ -2976,7 +2976,7 @@
           <a:bodyPr/>
           <a:lstStyle/>
           <a:p>
-            <a:fld id="{D559EA92-F8DF-420E-A5E8-4940031E9E8E}" type="slidenum">
+            <a:fld id="{358B2D0C-41AD-44D7-BAEA-F8F9A99E35C6}" type="slidenum">
               <a:rPr kumimoji="1" lang="ja-JP" altLang="en-US" smtClean="0"/>
               <a:t>‹#›</a:t>
             </a:fld>
@@ -2987,7 +2987,7 @@
     </p:spTree>
     <p:extLst>
       <p:ext uri="{BB962C8B-B14F-4D97-AF65-F5344CB8AC3E}">
-        <p14:creationId xmlns:p14="http://schemas.microsoft.com/office/powerpoint/2010/main" val="3240900180"/>
+        <p14:creationId xmlns:p14="http://schemas.microsoft.com/office/powerpoint/2010/main" val="1099884348"/>
       </p:ext>
     </p:extLst>
   </p:cSld>
@@ -3024,7 +3024,7 @@
           <p:cNvPr id="2" name="タイトル プレースホルダー 1">
             <a:extLst>
               <a:ext uri="{FF2B5EF4-FFF2-40B4-BE49-F238E27FC236}">
-                <a16:creationId xmlns:a16="http://schemas.microsoft.com/office/drawing/2014/main" id="{EB228F17-16C7-94BE-4562-336722A06019}"/>
+                <a16:creationId xmlns:a16="http://schemas.microsoft.com/office/drawing/2014/main" id="{7E410459-EC41-1F3F-B573-F6F5B50020CD}"/>
               </a:ext>
             </a:extLst>
           </p:cNvPr>
@@ -3062,7 +3062,7 @@
           <p:cNvPr id="3" name="テキスト プレースホルダー 2">
             <a:extLst>
               <a:ext uri="{FF2B5EF4-FFF2-40B4-BE49-F238E27FC236}">
-                <a16:creationId xmlns:a16="http://schemas.microsoft.com/office/drawing/2014/main" id="{FDE045B9-776D-BB9D-57BE-F39D62B255CD}"/>
+                <a16:creationId xmlns:a16="http://schemas.microsoft.com/office/drawing/2014/main" id="{B01231DD-8470-E849-4585-E025C89EE81C}"/>
               </a:ext>
             </a:extLst>
           </p:cNvPr>
@@ -3161,7 +3161,7 @@
           <p:cNvPr id="4" name="日付プレースホルダー 3">
             <a:extLst>
               <a:ext uri="{FF2B5EF4-FFF2-40B4-BE49-F238E27FC236}">
-                <a16:creationId xmlns:a16="http://schemas.microsoft.com/office/drawing/2014/main" id="{115927C0-AEF6-65C8-B18C-9C85909B3674}"/>
+                <a16:creationId xmlns:a16="http://schemas.microsoft.com/office/drawing/2014/main" id="{DE6CA459-A731-156D-0B1A-440632D1019B}"/>
               </a:ext>
             </a:extLst>
           </p:cNvPr>
@@ -3195,7 +3195,7 @@
             </a:lvl1pPr>
           </a:lstStyle>
           <a:p>
-            <a:fld id="{4ABB2253-A87D-461A-BEF5-E9762CC1454B}" type="datetimeFigureOut">
+            <a:fld id="{E36B06F2-3DC0-4847-A1E4-4EFDA763A8E6}" type="datetimeFigureOut">
               <a:rPr kumimoji="1" lang="ja-JP" altLang="en-US" smtClean="0"/>
               <a:t>2026/8/2</a:t>
             </a:fld>
@@ -3208,7 +3208,7 @@
           <p:cNvPr id="5" name="フッター プレースホルダー 4">
             <a:extLst>
               <a:ext uri="{FF2B5EF4-FFF2-40B4-BE49-F238E27FC236}">
-                <a16:creationId xmlns:a16="http://schemas.microsoft.com/office/drawing/2014/main" id="{35E2B1C2-BF94-BC67-A4C9-14A8A4E400F0}"/>
+                <a16:creationId xmlns:a16="http://schemas.microsoft.com/office/drawing/2014/main" id="{9E7F86F2-0051-43E8-D642-6876F0133D2B}"/>
               </a:ext>
             </a:extLst>
           </p:cNvPr>
@@ -3251,7 +3251,7 @@
           <p:cNvPr id="6" name="スライド番号プレースホルダー 5">
             <a:extLst>
               <a:ext uri="{FF2B5EF4-FFF2-40B4-BE49-F238E27FC236}">
-                <a16:creationId xmlns:a16="http://schemas.microsoft.com/office/drawing/2014/main" id="{A144390E-E1A8-5318-385F-57F0FAF08E1C}"/>
+                <a16:creationId xmlns:a16="http://schemas.microsoft.com/office/drawing/2014/main" id="{B602F5E5-C701-EDCD-B44C-08676F0046CD}"/>
               </a:ext>
             </a:extLst>
           </p:cNvPr>
@@ -3285,7 +3285,7 @@
             </a:lvl1pPr>
           </a:lstStyle>
           <a:p>
-            <a:fld id="{D559EA92-F8DF-420E-A5E8-4940031E9E8E}" type="slidenum">
+            <a:fld id="{358B2D0C-41AD-44D7-BAEA-F8F9A99E35C6}" type="slidenum">
               <a:rPr kumimoji="1" lang="ja-JP" altLang="en-US" smtClean="0"/>
               <a:t>‹#›</a:t>
             </a:fld>
@@ -3296,7 +3296,7 @@
     </p:spTree>
     <p:extLst>
       <p:ext uri="{BB962C8B-B14F-4D97-AF65-F5344CB8AC3E}">
-        <p14:creationId xmlns:p14="http://schemas.microsoft.com/office/powerpoint/2010/main" val="610316873"/>
+        <p14:creationId xmlns:p14="http://schemas.microsoft.com/office/powerpoint/2010/main" val="1470106037"/>
       </p:ext>
     </p:extLst>
   </p:cSld>
@@ -3619,7 +3619,7 @@
           <p:cNvPr id="2" name="テキスト ボックス 1">
             <a:extLst>
               <a:ext uri="{FF2B5EF4-FFF2-40B4-BE49-F238E27FC236}">
-                <a16:creationId xmlns:a16="http://schemas.microsoft.com/office/drawing/2014/main" id="{623432BB-ACF9-86D7-38EB-105E1C0EFFC9}"/>
+                <a16:creationId xmlns:a16="http://schemas.microsoft.com/office/drawing/2014/main" id="{D9AAD1DD-38B5-7DAD-0641-05DABAF73302}"/>
               </a:ext>
             </a:extLst>
           </p:cNvPr>
@@ -3643,56 +3643,23 @@
           <a:lstStyle/>
           <a:p>
             <a:r>
-              <a:rPr kumimoji="1" lang="zh-TW" altLang="en-US" sz="1600" b="1">
+              <a:rPr kumimoji="1" lang="en-US" altLang="ja-JP" sz="1600" b="1">
                 <a:solidFill>
                   <a:srgbClr val="556F35"/>
                 </a:solidFill>
                 <a:latin typeface="Arial" panose="020B0604020202020204" pitchFamily="34" charset="0"/>
               </a:rPr>
-              <a:t>遨阪∩荳翫￡繝ｭ繧ｰ </a:t>
-            </a:r>
-            <a:r>
-              <a:rPr kumimoji="1" lang="en-US" altLang="zh-TW" sz="1600" b="1">
+              <a:t>King Epark Neo</a:t>
+            </a:r>
+            <a:r>
+              <a:rPr kumimoji="1" lang="ja-JP" altLang="en-US" sz="1600" b="1">
                 <a:solidFill>
                   <a:srgbClr val="556F35"/>
                 </a:solidFill>
                 <a:latin typeface="Arial" panose="020B0604020202020204" pitchFamily="34" charset="0"/>
               </a:rPr>
-              <a:t>/ </a:t>
-            </a:r>
-            <a:r>
-              <a:rPr kumimoji="1" lang="zh-TW" altLang="en-US" sz="1600" b="1">
-                <a:solidFill>
-                  <a:srgbClr val="556F35"/>
-                </a:solidFill>
-                <a:latin typeface="Arial" panose="020B0604020202020204" pitchFamily="34" charset="0"/>
-              </a:rPr>
-              <a:t>謚陦楢ｧ</a:t>
-            </a:r>
-            <a:r>
-              <a:rPr kumimoji="1" lang="en-US" altLang="zh-TW" sz="1600" b="1">
-                <a:solidFill>
-                  <a:srgbClr val="556F35"/>
-                </a:solidFill>
-                <a:latin typeface="Arial" panose="020B0604020202020204" pitchFamily="34" charset="0"/>
-              </a:rPr>
-              <a:t>｣</a:t>
-            </a:r>
-            <a:r>
-              <a:rPr kumimoji="1" lang="zh-TW" altLang="en-US" sz="1600" b="1">
-                <a:solidFill>
-                  <a:srgbClr val="556F35"/>
-                </a:solidFill>
-                <a:latin typeface="Arial" panose="020B0604020202020204" pitchFamily="34" charset="0"/>
-              </a:rPr>
-              <a:t>隱ｬ蜍慕判</a:t>
-            </a:r>
-            <a:endParaRPr kumimoji="1" lang="ja-JP" altLang="en-US" sz="1600" b="1">
-              <a:solidFill>
-                <a:srgbClr val="556F35"/>
-              </a:solidFill>
-              <a:latin typeface="Arial" panose="020B0604020202020204" pitchFamily="34" charset="0"/>
-            </a:endParaRPr>
+              <a:t>の技術解説</a:t>
+            </a:r>
           </a:p>
         </p:txBody>
       </p:sp>
@@ -3701,7 +3668,7 @@
           <p:cNvPr id="3" name="テキスト ボックス 2">
             <a:extLst>
               <a:ext uri="{FF2B5EF4-FFF2-40B4-BE49-F238E27FC236}">
-                <a16:creationId xmlns:a16="http://schemas.microsoft.com/office/drawing/2014/main" id="{FFA248E5-C104-550C-8677-5BB865E4EFFD}"/>
+                <a16:creationId xmlns:a16="http://schemas.microsoft.com/office/drawing/2014/main" id="{B0AAAFD3-2268-E51D-9515-6FB79F64BB20}"/>
               </a:ext>
             </a:extLst>
           </p:cNvPr>
@@ -3750,7 +3717,7 @@
           <p:cNvPr id="4" name="テキスト ボックス 3">
             <a:extLst>
               <a:ext uri="{FF2B5EF4-FFF2-40B4-BE49-F238E27FC236}">
-                <a16:creationId xmlns:a16="http://schemas.microsoft.com/office/drawing/2014/main" id="{F5277485-C633-2B73-0A09-10641E4A0E5A}"/>
+                <a16:creationId xmlns:a16="http://schemas.microsoft.com/office/drawing/2014/main" id="{2B76A7C6-4A50-0065-AA65-8F74568E2A81}"/>
               </a:ext>
             </a:extLst>
           </p:cNvPr>
@@ -3790,7 +3757,7 @@
           <p:cNvPr id="5" name="テキスト ボックス 4">
             <a:extLst>
               <a:ext uri="{FF2B5EF4-FFF2-40B4-BE49-F238E27FC236}">
-                <a16:creationId xmlns:a16="http://schemas.microsoft.com/office/drawing/2014/main" id="{E8B221AC-149E-995D-4B1E-2BD3B88B8221}"/>
+                <a16:creationId xmlns:a16="http://schemas.microsoft.com/office/drawing/2014/main" id="{EDDEFBA2-4E21-7244-0E61-816C3ED4AF0C}"/>
               </a:ext>
             </a:extLst>
           </p:cNvPr>
@@ -3837,7 +3804,7 @@
             <a:hlinkClick r:id="" action="ppaction://media"/>
             <a:extLst>
               <a:ext uri="{FF2B5EF4-FFF2-40B4-BE49-F238E27FC236}">
-                <a16:creationId xmlns:a16="http://schemas.microsoft.com/office/drawing/2014/main" id="{2B7D017F-2311-AE97-9306-F4CF7E11AFC8}"/>
+                <a16:creationId xmlns:a16="http://schemas.microsoft.com/office/drawing/2014/main" id="{28397B00-0410-88CD-FE4A-BDF7854F7753}"/>
               </a:ext>
             </a:extLst>
           </p:cNvPr>
@@ -3872,7 +3839,7 @@
     </p:spTree>
     <p:extLst>
       <p:ext uri="{BB962C8B-B14F-4D97-AF65-F5344CB8AC3E}">
-        <p14:creationId xmlns:p14="http://schemas.microsoft.com/office/powerpoint/2010/main" val="2268539316"/>
+        <p14:creationId xmlns:p14="http://schemas.microsoft.com/office/powerpoint/2010/main" val="303014359"/>
       </p:ext>
     </p:extLst>
   </p:cSld>
@@ -3996,7 +3963,7 @@
           <p:cNvPr id="2" name="テキスト ボックス 1">
             <a:extLst>
               <a:ext uri="{FF2B5EF4-FFF2-40B4-BE49-F238E27FC236}">
-                <a16:creationId xmlns:a16="http://schemas.microsoft.com/office/drawing/2014/main" id="{05F67EDE-A49C-5D94-9AA1-D44293F54262}"/>
+                <a16:creationId xmlns:a16="http://schemas.microsoft.com/office/drawing/2014/main" id="{F807B6B9-DCB9-AB9A-E524-AE3196EC0B9A}"/>
               </a:ext>
             </a:extLst>
           </p:cNvPr>
@@ -4020,56 +3987,23 @@
           <a:lstStyle/>
           <a:p>
             <a:r>
-              <a:rPr kumimoji="1" lang="zh-TW" altLang="en-US" sz="1600" b="1">
+              <a:rPr kumimoji="1" lang="en-US" altLang="ja-JP" sz="1600" b="1">
                 <a:solidFill>
                   <a:srgbClr val="556F35"/>
                 </a:solidFill>
                 <a:latin typeface="Arial" panose="020B0604020202020204" pitchFamily="34" charset="0"/>
               </a:rPr>
-              <a:t>遨阪∩荳翫￡繝ｭ繧ｰ </a:t>
-            </a:r>
-            <a:r>
-              <a:rPr kumimoji="1" lang="en-US" altLang="zh-TW" sz="1600" b="1">
+              <a:t>King Epark Neo</a:t>
+            </a:r>
+            <a:r>
+              <a:rPr kumimoji="1" lang="ja-JP" altLang="en-US" sz="1600" b="1">
                 <a:solidFill>
                   <a:srgbClr val="556F35"/>
                 </a:solidFill>
                 <a:latin typeface="Arial" panose="020B0604020202020204" pitchFamily="34" charset="0"/>
               </a:rPr>
-              <a:t>/ </a:t>
-            </a:r>
-            <a:r>
-              <a:rPr kumimoji="1" lang="zh-TW" altLang="en-US" sz="1600" b="1">
-                <a:solidFill>
-                  <a:srgbClr val="556F35"/>
-                </a:solidFill>
-                <a:latin typeface="Arial" panose="020B0604020202020204" pitchFamily="34" charset="0"/>
-              </a:rPr>
-              <a:t>謚陦楢ｧ</a:t>
-            </a:r>
-            <a:r>
-              <a:rPr kumimoji="1" lang="en-US" altLang="zh-TW" sz="1600" b="1">
-                <a:solidFill>
-                  <a:srgbClr val="556F35"/>
-                </a:solidFill>
-                <a:latin typeface="Arial" panose="020B0604020202020204" pitchFamily="34" charset="0"/>
-              </a:rPr>
-              <a:t>｣</a:t>
-            </a:r>
-            <a:r>
-              <a:rPr kumimoji="1" lang="zh-TW" altLang="en-US" sz="1600" b="1">
-                <a:solidFill>
-                  <a:srgbClr val="556F35"/>
-                </a:solidFill>
-                <a:latin typeface="Arial" panose="020B0604020202020204" pitchFamily="34" charset="0"/>
-              </a:rPr>
-              <a:t>隱ｬ蜍慕判</a:t>
-            </a:r>
-            <a:endParaRPr kumimoji="1" lang="ja-JP" altLang="en-US" sz="1600" b="1">
-              <a:solidFill>
-                <a:srgbClr val="556F35"/>
-              </a:solidFill>
-              <a:latin typeface="Arial" panose="020B0604020202020204" pitchFamily="34" charset="0"/>
-            </a:endParaRPr>
+              <a:t>の技術解説</a:t>
+            </a:r>
           </a:p>
         </p:txBody>
       </p:sp>
@@ -4078,7 +4012,7 @@
           <p:cNvPr id="3" name="テキスト ボックス 2">
             <a:extLst>
               <a:ext uri="{FF2B5EF4-FFF2-40B4-BE49-F238E27FC236}">
-                <a16:creationId xmlns:a16="http://schemas.microsoft.com/office/drawing/2014/main" id="{932D8EC4-1271-C347-438E-9F6C5654A713}"/>
+                <a16:creationId xmlns:a16="http://schemas.microsoft.com/office/drawing/2014/main" id="{49FCFEA6-DE8E-8369-1E71-63AF2FC2BCA8}"/>
               </a:ext>
             </a:extLst>
           </p:cNvPr>
@@ -4118,7 +4052,7 @@
           <p:cNvPr id="4" name="テキスト ボックス 3">
             <a:extLst>
               <a:ext uri="{FF2B5EF4-FFF2-40B4-BE49-F238E27FC236}">
-                <a16:creationId xmlns:a16="http://schemas.microsoft.com/office/drawing/2014/main" id="{C853EEA1-BA31-3F14-BDAB-72C0B8148F05}"/>
+                <a16:creationId xmlns:a16="http://schemas.microsoft.com/office/drawing/2014/main" id="{D24AAA06-A16D-90AC-E1EC-58297E60E4C5}"/>
               </a:ext>
             </a:extLst>
           </p:cNvPr>
@@ -4221,7 +4155,7 @@
           <p:cNvPr id="5" name="テキスト ボックス 4">
             <a:extLst>
               <a:ext uri="{FF2B5EF4-FFF2-40B4-BE49-F238E27FC236}">
-                <a16:creationId xmlns:a16="http://schemas.microsoft.com/office/drawing/2014/main" id="{9B164A2F-F58F-31F0-8024-F873A12E0590}"/>
+                <a16:creationId xmlns:a16="http://schemas.microsoft.com/office/drawing/2014/main" id="{9B7AAC55-BF5C-BA43-44B1-C2C4C7C21B4B}"/>
               </a:ext>
             </a:extLst>
           </p:cNvPr>
@@ -4268,7 +4202,7 @@
             <a:hlinkClick r:id="" action="ppaction://media"/>
             <a:extLst>
               <a:ext uri="{FF2B5EF4-FFF2-40B4-BE49-F238E27FC236}">
-                <a16:creationId xmlns:a16="http://schemas.microsoft.com/office/drawing/2014/main" id="{86FBE652-7614-6AE3-2E65-5F1EEEDCE571}"/>
+                <a16:creationId xmlns:a16="http://schemas.microsoft.com/office/drawing/2014/main" id="{2CE012B4-A0CD-05E2-6480-9A658EEA1A4E}"/>
               </a:ext>
             </a:extLst>
           </p:cNvPr>
@@ -4303,7 +4237,7 @@
     </p:spTree>
     <p:extLst>
       <p:ext uri="{BB962C8B-B14F-4D97-AF65-F5344CB8AC3E}">
-        <p14:creationId xmlns:p14="http://schemas.microsoft.com/office/powerpoint/2010/main" val="1717018984"/>
+        <p14:creationId xmlns:p14="http://schemas.microsoft.com/office/powerpoint/2010/main" val="3753508584"/>
       </p:ext>
     </p:extLst>
   </p:cSld>
@@ -4427,7 +4361,7 @@
           <p:cNvPr id="2" name="テキスト ボックス 1">
             <a:extLst>
               <a:ext uri="{FF2B5EF4-FFF2-40B4-BE49-F238E27FC236}">
-                <a16:creationId xmlns:a16="http://schemas.microsoft.com/office/drawing/2014/main" id="{34ACFAC0-2DDF-77DB-A6C7-CEE6EFDB4E5B}"/>
+                <a16:creationId xmlns:a16="http://schemas.microsoft.com/office/drawing/2014/main" id="{8A4FF144-76E8-FFC2-D77E-E5753200A20F}"/>
               </a:ext>
             </a:extLst>
           </p:cNvPr>
@@ -4451,56 +4385,23 @@
           <a:lstStyle/>
           <a:p>
             <a:r>
-              <a:rPr kumimoji="1" lang="zh-TW" altLang="en-US" sz="1600" b="1">
+              <a:rPr kumimoji="1" lang="en-US" altLang="ja-JP" sz="1600" b="1">
                 <a:solidFill>
                   <a:srgbClr val="556F35"/>
                 </a:solidFill>
                 <a:latin typeface="Arial" panose="020B0604020202020204" pitchFamily="34" charset="0"/>
               </a:rPr>
-              <a:t>遨阪∩荳翫￡繝ｭ繧ｰ </a:t>
-            </a:r>
-            <a:r>
-              <a:rPr kumimoji="1" lang="en-US" altLang="zh-TW" sz="1600" b="1">
+              <a:t>King Epark Neo</a:t>
+            </a:r>
+            <a:r>
+              <a:rPr kumimoji="1" lang="ja-JP" altLang="en-US" sz="1600" b="1">
                 <a:solidFill>
                   <a:srgbClr val="556F35"/>
                 </a:solidFill>
                 <a:latin typeface="Arial" panose="020B0604020202020204" pitchFamily="34" charset="0"/>
               </a:rPr>
-              <a:t>/ </a:t>
-            </a:r>
-            <a:r>
-              <a:rPr kumimoji="1" lang="zh-TW" altLang="en-US" sz="1600" b="1">
-                <a:solidFill>
-                  <a:srgbClr val="556F35"/>
-                </a:solidFill>
-                <a:latin typeface="Arial" panose="020B0604020202020204" pitchFamily="34" charset="0"/>
-              </a:rPr>
-              <a:t>謚陦楢ｧ</a:t>
-            </a:r>
-            <a:r>
-              <a:rPr kumimoji="1" lang="en-US" altLang="zh-TW" sz="1600" b="1">
-                <a:solidFill>
-                  <a:srgbClr val="556F35"/>
-                </a:solidFill>
-                <a:latin typeface="Arial" panose="020B0604020202020204" pitchFamily="34" charset="0"/>
-              </a:rPr>
-              <a:t>｣</a:t>
-            </a:r>
-            <a:r>
-              <a:rPr kumimoji="1" lang="zh-TW" altLang="en-US" sz="1600" b="1">
-                <a:solidFill>
-                  <a:srgbClr val="556F35"/>
-                </a:solidFill>
-                <a:latin typeface="Arial" panose="020B0604020202020204" pitchFamily="34" charset="0"/>
-              </a:rPr>
-              <a:t>隱ｬ蜍慕判</a:t>
-            </a:r>
-            <a:endParaRPr kumimoji="1" lang="ja-JP" altLang="en-US" sz="1600" b="1">
-              <a:solidFill>
-                <a:srgbClr val="556F35"/>
-              </a:solidFill>
-              <a:latin typeface="Arial" panose="020B0604020202020204" pitchFamily="34" charset="0"/>
-            </a:endParaRPr>
+              <a:t>の技術解説</a:t>
+            </a:r>
           </a:p>
         </p:txBody>
       </p:sp>
@@ -4509,7 +4410,7 @@
           <p:cNvPr id="3" name="テキスト ボックス 2">
             <a:extLst>
               <a:ext uri="{FF2B5EF4-FFF2-40B4-BE49-F238E27FC236}">
-                <a16:creationId xmlns:a16="http://schemas.microsoft.com/office/drawing/2014/main" id="{33F3DABA-5E07-3DB7-BCA6-FA75B9C15400}"/>
+                <a16:creationId xmlns:a16="http://schemas.microsoft.com/office/drawing/2014/main" id="{ED977A47-B1F9-B1E7-C6AC-28857BF0870A}"/>
               </a:ext>
             </a:extLst>
           </p:cNvPr>
@@ -4549,7 +4450,7 @@
           <p:cNvPr id="4" name="テキスト ボックス 3">
             <a:extLst>
               <a:ext uri="{FF2B5EF4-FFF2-40B4-BE49-F238E27FC236}">
-                <a16:creationId xmlns:a16="http://schemas.microsoft.com/office/drawing/2014/main" id="{DFD34C1A-B8EE-5F63-79C8-6DC739257F97}"/>
+                <a16:creationId xmlns:a16="http://schemas.microsoft.com/office/drawing/2014/main" id="{71C406D3-503A-E2B8-8711-DB1EC33C2CAA}"/>
               </a:ext>
             </a:extLst>
           </p:cNvPr>
@@ -4644,7 +4545,7 @@
           <p:cNvPr id="5" name="テキスト ボックス 4">
             <a:extLst>
               <a:ext uri="{FF2B5EF4-FFF2-40B4-BE49-F238E27FC236}">
-                <a16:creationId xmlns:a16="http://schemas.microsoft.com/office/drawing/2014/main" id="{1C27C3A1-C8CB-EBB6-29B5-DE1632958A05}"/>
+                <a16:creationId xmlns:a16="http://schemas.microsoft.com/office/drawing/2014/main" id="{93EAFF9C-53FC-042B-5CDE-0D1626639E50}"/>
               </a:ext>
             </a:extLst>
           </p:cNvPr>
@@ -4691,7 +4592,7 @@
             <a:hlinkClick r:id="" action="ppaction://media"/>
             <a:extLst>
               <a:ext uri="{FF2B5EF4-FFF2-40B4-BE49-F238E27FC236}">
-                <a16:creationId xmlns:a16="http://schemas.microsoft.com/office/drawing/2014/main" id="{1B8A6D3F-DF90-084A-4CBB-2DC91D723756}"/>
+                <a16:creationId xmlns:a16="http://schemas.microsoft.com/office/drawing/2014/main" id="{22079EAA-BE6D-81E1-05D8-0B504B07893C}"/>
               </a:ext>
             </a:extLst>
           </p:cNvPr>
@@ -4726,7 +4627,7 @@
     </p:spTree>
     <p:extLst>
       <p:ext uri="{BB962C8B-B14F-4D97-AF65-F5344CB8AC3E}">
-        <p14:creationId xmlns:p14="http://schemas.microsoft.com/office/powerpoint/2010/main" val="2482021698"/>
+        <p14:creationId xmlns:p14="http://schemas.microsoft.com/office/powerpoint/2010/main" val="306677933"/>
       </p:ext>
     </p:extLst>
   </p:cSld>
@@ -4850,7 +4751,7 @@
           <p:cNvPr id="2" name="テキスト ボックス 1">
             <a:extLst>
               <a:ext uri="{FF2B5EF4-FFF2-40B4-BE49-F238E27FC236}">
-                <a16:creationId xmlns:a16="http://schemas.microsoft.com/office/drawing/2014/main" id="{21BCB48E-A399-CE43-BD80-4406BE7FE58F}"/>
+                <a16:creationId xmlns:a16="http://schemas.microsoft.com/office/drawing/2014/main" id="{AADEC3E0-8612-9535-1483-1E54E29F72EF}"/>
               </a:ext>
             </a:extLst>
           </p:cNvPr>
@@ -4874,56 +4775,23 @@
           <a:lstStyle/>
           <a:p>
             <a:r>
-              <a:rPr kumimoji="1" lang="zh-TW" altLang="en-US" sz="1600" b="1">
+              <a:rPr kumimoji="1" lang="en-US" altLang="ja-JP" sz="1600" b="1">
                 <a:solidFill>
                   <a:srgbClr val="556F35"/>
                 </a:solidFill>
                 <a:latin typeface="Arial" panose="020B0604020202020204" pitchFamily="34" charset="0"/>
               </a:rPr>
-              <a:t>遨阪∩荳翫￡繝ｭ繧ｰ </a:t>
-            </a:r>
-            <a:r>
-              <a:rPr kumimoji="1" lang="en-US" altLang="zh-TW" sz="1600" b="1">
+              <a:t>King Epark Neo</a:t>
+            </a:r>
+            <a:r>
+              <a:rPr kumimoji="1" lang="ja-JP" altLang="en-US" sz="1600" b="1">
                 <a:solidFill>
                   <a:srgbClr val="556F35"/>
                 </a:solidFill>
                 <a:latin typeface="Arial" panose="020B0604020202020204" pitchFamily="34" charset="0"/>
               </a:rPr>
-              <a:t>/ </a:t>
-            </a:r>
-            <a:r>
-              <a:rPr kumimoji="1" lang="zh-TW" altLang="en-US" sz="1600" b="1">
-                <a:solidFill>
-                  <a:srgbClr val="556F35"/>
-                </a:solidFill>
-                <a:latin typeface="Arial" panose="020B0604020202020204" pitchFamily="34" charset="0"/>
-              </a:rPr>
-              <a:t>謚陦楢ｧ</a:t>
-            </a:r>
-            <a:r>
-              <a:rPr kumimoji="1" lang="en-US" altLang="zh-TW" sz="1600" b="1">
-                <a:solidFill>
-                  <a:srgbClr val="556F35"/>
-                </a:solidFill>
-                <a:latin typeface="Arial" panose="020B0604020202020204" pitchFamily="34" charset="0"/>
-              </a:rPr>
-              <a:t>｣</a:t>
-            </a:r>
-            <a:r>
-              <a:rPr kumimoji="1" lang="zh-TW" altLang="en-US" sz="1600" b="1">
-                <a:solidFill>
-                  <a:srgbClr val="556F35"/>
-                </a:solidFill>
-                <a:latin typeface="Arial" panose="020B0604020202020204" pitchFamily="34" charset="0"/>
-              </a:rPr>
-              <a:t>隱ｬ蜍慕判</a:t>
-            </a:r>
-            <a:endParaRPr kumimoji="1" lang="ja-JP" altLang="en-US" sz="1600" b="1">
-              <a:solidFill>
-                <a:srgbClr val="556F35"/>
-              </a:solidFill>
-              <a:latin typeface="Arial" panose="020B0604020202020204" pitchFamily="34" charset="0"/>
-            </a:endParaRPr>
+              <a:t>の技術解説</a:t>
+            </a:r>
           </a:p>
         </p:txBody>
       </p:sp>
@@ -4932,7 +4800,7 @@
           <p:cNvPr id="3" name="テキスト ボックス 2">
             <a:extLst>
               <a:ext uri="{FF2B5EF4-FFF2-40B4-BE49-F238E27FC236}">
-                <a16:creationId xmlns:a16="http://schemas.microsoft.com/office/drawing/2014/main" id="{24A2C5F0-ADFB-F3F6-3E2D-4718D26F11CD}"/>
+                <a16:creationId xmlns:a16="http://schemas.microsoft.com/office/drawing/2014/main" id="{06EDC626-D739-7109-B14E-5A77F5D561D4}"/>
               </a:ext>
             </a:extLst>
           </p:cNvPr>
@@ -4972,7 +4840,7 @@
           <p:cNvPr id="4" name="テキスト ボックス 3">
             <a:extLst>
               <a:ext uri="{FF2B5EF4-FFF2-40B4-BE49-F238E27FC236}">
-                <a16:creationId xmlns:a16="http://schemas.microsoft.com/office/drawing/2014/main" id="{E06F6C7F-AAC9-B4F3-0FAA-AF1A4CC8861B}"/>
+                <a16:creationId xmlns:a16="http://schemas.microsoft.com/office/drawing/2014/main" id="{E3197068-06D6-07E8-DA4E-A065DE7C9EDA}"/>
               </a:ext>
             </a:extLst>
           </p:cNvPr>
@@ -5082,7 +4950,7 @@
           <p:cNvPr id="5" name="テキスト ボックス 4">
             <a:extLst>
               <a:ext uri="{FF2B5EF4-FFF2-40B4-BE49-F238E27FC236}">
-                <a16:creationId xmlns:a16="http://schemas.microsoft.com/office/drawing/2014/main" id="{F521594D-A7AF-E679-0D9C-0A038724ABA9}"/>
+                <a16:creationId xmlns:a16="http://schemas.microsoft.com/office/drawing/2014/main" id="{5AFDE1FF-BD86-B57E-D0A2-F049EB485F54}"/>
               </a:ext>
             </a:extLst>
           </p:cNvPr>
@@ -5129,7 +4997,7 @@
             <a:hlinkClick r:id="" action="ppaction://media"/>
             <a:extLst>
               <a:ext uri="{FF2B5EF4-FFF2-40B4-BE49-F238E27FC236}">
-                <a16:creationId xmlns:a16="http://schemas.microsoft.com/office/drawing/2014/main" id="{B2872CB5-2DDD-54BE-16FA-7F64B5F70FCE}"/>
+                <a16:creationId xmlns:a16="http://schemas.microsoft.com/office/drawing/2014/main" id="{E816330A-093B-79B9-DD2F-15B341FD278A}"/>
               </a:ext>
             </a:extLst>
           </p:cNvPr>
@@ -5164,7 +5032,7 @@
     </p:spTree>
     <p:extLst>
       <p:ext uri="{BB962C8B-B14F-4D97-AF65-F5344CB8AC3E}">
-        <p14:creationId xmlns:p14="http://schemas.microsoft.com/office/powerpoint/2010/main" val="1217545784"/>
+        <p14:creationId xmlns:p14="http://schemas.microsoft.com/office/powerpoint/2010/main" val="3940100460"/>
       </p:ext>
     </p:extLst>
   </p:cSld>
@@ -5288,7 +5156,7 @@
           <p:cNvPr id="2" name="テキスト ボックス 1">
             <a:extLst>
               <a:ext uri="{FF2B5EF4-FFF2-40B4-BE49-F238E27FC236}">
-                <a16:creationId xmlns:a16="http://schemas.microsoft.com/office/drawing/2014/main" id="{539E687F-9E72-C8D0-7384-BDA2B3718E3E}"/>
+                <a16:creationId xmlns:a16="http://schemas.microsoft.com/office/drawing/2014/main" id="{3D7F8E71-899A-A1AB-8C34-8F334476346C}"/>
               </a:ext>
             </a:extLst>
           </p:cNvPr>
@@ -5312,56 +5180,23 @@
           <a:lstStyle/>
           <a:p>
             <a:r>
-              <a:rPr kumimoji="1" lang="zh-TW" altLang="en-US" sz="1600" b="1">
+              <a:rPr kumimoji="1" lang="en-US" altLang="ja-JP" sz="1600" b="1">
                 <a:solidFill>
                   <a:srgbClr val="556F35"/>
                 </a:solidFill>
                 <a:latin typeface="Arial" panose="020B0604020202020204" pitchFamily="34" charset="0"/>
               </a:rPr>
-              <a:t>遨阪∩荳翫￡繝ｭ繧ｰ </a:t>
-            </a:r>
-            <a:r>
-              <a:rPr kumimoji="1" lang="en-US" altLang="zh-TW" sz="1600" b="1">
+              <a:t>King Epark Neo</a:t>
+            </a:r>
+            <a:r>
+              <a:rPr kumimoji="1" lang="ja-JP" altLang="en-US" sz="1600" b="1">
                 <a:solidFill>
                   <a:srgbClr val="556F35"/>
                 </a:solidFill>
                 <a:latin typeface="Arial" panose="020B0604020202020204" pitchFamily="34" charset="0"/>
               </a:rPr>
-              <a:t>/ </a:t>
-            </a:r>
-            <a:r>
-              <a:rPr kumimoji="1" lang="zh-TW" altLang="en-US" sz="1600" b="1">
-                <a:solidFill>
-                  <a:srgbClr val="556F35"/>
-                </a:solidFill>
-                <a:latin typeface="Arial" panose="020B0604020202020204" pitchFamily="34" charset="0"/>
-              </a:rPr>
-              <a:t>謚陦楢ｧ</a:t>
-            </a:r>
-            <a:r>
-              <a:rPr kumimoji="1" lang="en-US" altLang="zh-TW" sz="1600" b="1">
-                <a:solidFill>
-                  <a:srgbClr val="556F35"/>
-                </a:solidFill>
-                <a:latin typeface="Arial" panose="020B0604020202020204" pitchFamily="34" charset="0"/>
-              </a:rPr>
-              <a:t>｣</a:t>
-            </a:r>
-            <a:r>
-              <a:rPr kumimoji="1" lang="zh-TW" altLang="en-US" sz="1600" b="1">
-                <a:solidFill>
-                  <a:srgbClr val="556F35"/>
-                </a:solidFill>
-                <a:latin typeface="Arial" panose="020B0604020202020204" pitchFamily="34" charset="0"/>
-              </a:rPr>
-              <a:t>隱ｬ蜍慕判</a:t>
-            </a:r>
-            <a:endParaRPr kumimoji="1" lang="ja-JP" altLang="en-US" sz="1600" b="1">
-              <a:solidFill>
-                <a:srgbClr val="556F35"/>
-              </a:solidFill>
-              <a:latin typeface="Arial" panose="020B0604020202020204" pitchFamily="34" charset="0"/>
-            </a:endParaRPr>
+              <a:t>の技術解説</a:t>
+            </a:r>
           </a:p>
         </p:txBody>
       </p:sp>
@@ -5370,7 +5205,7 @@
           <p:cNvPr id="3" name="テキスト ボックス 2">
             <a:extLst>
               <a:ext uri="{FF2B5EF4-FFF2-40B4-BE49-F238E27FC236}">
-                <a16:creationId xmlns:a16="http://schemas.microsoft.com/office/drawing/2014/main" id="{722DDB55-D40E-118B-9228-CA9E7AB55B06}"/>
+                <a16:creationId xmlns:a16="http://schemas.microsoft.com/office/drawing/2014/main" id="{EC107ABC-7614-D214-C65A-4CA2F2E61738}"/>
               </a:ext>
             </a:extLst>
           </p:cNvPr>
@@ -5410,7 +5245,7 @@
           <p:cNvPr id="4" name="テキスト ボックス 3">
             <a:extLst>
               <a:ext uri="{FF2B5EF4-FFF2-40B4-BE49-F238E27FC236}">
-                <a16:creationId xmlns:a16="http://schemas.microsoft.com/office/drawing/2014/main" id="{3BD69980-E6F1-D8BC-7250-994F96819338}"/>
+                <a16:creationId xmlns:a16="http://schemas.microsoft.com/office/drawing/2014/main" id="{7A3842FE-BCF6-C6C8-8DE8-BABD6571EC5E}"/>
               </a:ext>
             </a:extLst>
           </p:cNvPr>
@@ -5450,7 +5285,7 @@
           <p:cNvPr id="5" name="テキスト ボックス 4">
             <a:extLst>
               <a:ext uri="{FF2B5EF4-FFF2-40B4-BE49-F238E27FC236}">
-                <a16:creationId xmlns:a16="http://schemas.microsoft.com/office/drawing/2014/main" id="{8F051C23-29DC-026D-635F-139D8CB10196}"/>
+                <a16:creationId xmlns:a16="http://schemas.microsoft.com/office/drawing/2014/main" id="{9A7FEB17-89C3-A5B0-3CF0-FD3E38C38F36}"/>
               </a:ext>
             </a:extLst>
           </p:cNvPr>
@@ -5497,7 +5332,7 @@
             <a:hlinkClick r:id="" action="ppaction://media"/>
             <a:extLst>
               <a:ext uri="{FF2B5EF4-FFF2-40B4-BE49-F238E27FC236}">
-                <a16:creationId xmlns:a16="http://schemas.microsoft.com/office/drawing/2014/main" id="{9BACC697-6866-80EE-6F71-AB050DED8DEB}"/>
+                <a16:creationId xmlns:a16="http://schemas.microsoft.com/office/drawing/2014/main" id="{60CB5262-8B9B-FDC6-0762-71FA76A32779}"/>
               </a:ext>
             </a:extLst>
           </p:cNvPr>
@@ -5532,7 +5367,7 @@
     </p:spTree>
     <p:extLst>
       <p:ext uri="{BB962C8B-B14F-4D97-AF65-F5344CB8AC3E}">
-        <p14:creationId xmlns:p14="http://schemas.microsoft.com/office/powerpoint/2010/main" val="3047413724"/>
+        <p14:creationId xmlns:p14="http://schemas.microsoft.com/office/powerpoint/2010/main" val="1247468948"/>
       </p:ext>
     </p:extLst>
   </p:cSld>
@@ -5656,7 +5491,7 @@
           <p:cNvPr id="2" name="テキスト ボックス 1">
             <a:extLst>
               <a:ext uri="{FF2B5EF4-FFF2-40B4-BE49-F238E27FC236}">
-                <a16:creationId xmlns:a16="http://schemas.microsoft.com/office/drawing/2014/main" id="{5FABFDFD-EFB6-01DD-5E75-FE7FDFDE30AC}"/>
+                <a16:creationId xmlns:a16="http://schemas.microsoft.com/office/drawing/2014/main" id="{E59EB13A-6B26-013A-D5D0-A173B148373B}"/>
               </a:ext>
             </a:extLst>
           </p:cNvPr>
@@ -5680,56 +5515,23 @@
           <a:lstStyle/>
           <a:p>
             <a:r>
-              <a:rPr kumimoji="1" lang="zh-TW" altLang="en-US" sz="1600" b="1">
+              <a:rPr kumimoji="1" lang="en-US" altLang="ja-JP" sz="1600" b="1">
                 <a:solidFill>
                   <a:srgbClr val="556F35"/>
                 </a:solidFill>
                 <a:latin typeface="Arial" panose="020B0604020202020204" pitchFamily="34" charset="0"/>
               </a:rPr>
-              <a:t>遨阪∩荳翫￡繝ｭ繧ｰ </a:t>
-            </a:r>
-            <a:r>
-              <a:rPr kumimoji="1" lang="en-US" altLang="zh-TW" sz="1600" b="1">
+              <a:t>King Epark Neo</a:t>
+            </a:r>
+            <a:r>
+              <a:rPr kumimoji="1" lang="ja-JP" altLang="en-US" sz="1600" b="1">
                 <a:solidFill>
                   <a:srgbClr val="556F35"/>
                 </a:solidFill>
                 <a:latin typeface="Arial" panose="020B0604020202020204" pitchFamily="34" charset="0"/>
               </a:rPr>
-              <a:t>/ </a:t>
-            </a:r>
-            <a:r>
-              <a:rPr kumimoji="1" lang="zh-TW" altLang="en-US" sz="1600" b="1">
-                <a:solidFill>
-                  <a:srgbClr val="556F35"/>
-                </a:solidFill>
-                <a:latin typeface="Arial" panose="020B0604020202020204" pitchFamily="34" charset="0"/>
-              </a:rPr>
-              <a:t>謚陦楢ｧ</a:t>
-            </a:r>
-            <a:r>
-              <a:rPr kumimoji="1" lang="en-US" altLang="zh-TW" sz="1600" b="1">
-                <a:solidFill>
-                  <a:srgbClr val="556F35"/>
-                </a:solidFill>
-                <a:latin typeface="Arial" panose="020B0604020202020204" pitchFamily="34" charset="0"/>
-              </a:rPr>
-              <a:t>｣</a:t>
-            </a:r>
-            <a:r>
-              <a:rPr kumimoji="1" lang="zh-TW" altLang="en-US" sz="1600" b="1">
-                <a:solidFill>
-                  <a:srgbClr val="556F35"/>
-                </a:solidFill>
-                <a:latin typeface="Arial" panose="020B0604020202020204" pitchFamily="34" charset="0"/>
-              </a:rPr>
-              <a:t>隱ｬ蜍慕判</a:t>
-            </a:r>
-            <a:endParaRPr kumimoji="1" lang="ja-JP" altLang="en-US" sz="1600" b="1">
-              <a:solidFill>
-                <a:srgbClr val="556F35"/>
-              </a:solidFill>
-              <a:latin typeface="Arial" panose="020B0604020202020204" pitchFamily="34" charset="0"/>
-            </a:endParaRPr>
+              <a:t>の技術解説</a:t>
+            </a:r>
           </a:p>
         </p:txBody>
       </p:sp>
@@ -5738,7 +5540,7 @@
           <p:cNvPr id="3" name="テキスト ボックス 2">
             <a:extLst>
               <a:ext uri="{FF2B5EF4-FFF2-40B4-BE49-F238E27FC236}">
-                <a16:creationId xmlns:a16="http://schemas.microsoft.com/office/drawing/2014/main" id="{868B1C0D-4656-6F89-86E4-4F5CA9E30EA2}"/>
+                <a16:creationId xmlns:a16="http://schemas.microsoft.com/office/drawing/2014/main" id="{5C9D891C-C864-6144-1CA7-4E7EB61407CB}"/>
               </a:ext>
             </a:extLst>
           </p:cNvPr>
@@ -5778,7 +5580,7 @@
           <p:cNvPr id="4" name="テキスト ボックス 3">
             <a:extLst>
               <a:ext uri="{FF2B5EF4-FFF2-40B4-BE49-F238E27FC236}">
-                <a16:creationId xmlns:a16="http://schemas.microsoft.com/office/drawing/2014/main" id="{9652B779-9CB5-469B-A5DC-F3B855955CDB}"/>
+                <a16:creationId xmlns:a16="http://schemas.microsoft.com/office/drawing/2014/main" id="{4D8AAD67-1834-DC5C-9A04-AB836E095BB9}"/>
               </a:ext>
             </a:extLst>
           </p:cNvPr>
@@ -5843,7 +5645,7 @@
           <p:cNvPr id="5" name="テキスト ボックス 4">
             <a:extLst>
               <a:ext uri="{FF2B5EF4-FFF2-40B4-BE49-F238E27FC236}">
-                <a16:creationId xmlns:a16="http://schemas.microsoft.com/office/drawing/2014/main" id="{D561D33C-3C33-CF88-9973-FDA00056383E}"/>
+                <a16:creationId xmlns:a16="http://schemas.microsoft.com/office/drawing/2014/main" id="{CF0B669F-129A-07D6-DE7A-58A75C370AD0}"/>
               </a:ext>
             </a:extLst>
           </p:cNvPr>
@@ -5890,7 +5692,7 @@
             <a:hlinkClick r:id="" action="ppaction://media"/>
             <a:extLst>
               <a:ext uri="{FF2B5EF4-FFF2-40B4-BE49-F238E27FC236}">
-                <a16:creationId xmlns:a16="http://schemas.microsoft.com/office/drawing/2014/main" id="{76424C50-713A-9D4F-32FA-9410BE0CB55B}"/>
+                <a16:creationId xmlns:a16="http://schemas.microsoft.com/office/drawing/2014/main" id="{FEB92EBF-1D80-95D1-A02A-79EF648E9E2F}"/>
               </a:ext>
             </a:extLst>
           </p:cNvPr>
@@ -5925,7 +5727,7 @@
     </p:spTree>
     <p:extLst>
       <p:ext uri="{BB962C8B-B14F-4D97-AF65-F5344CB8AC3E}">
-        <p14:creationId xmlns:p14="http://schemas.microsoft.com/office/powerpoint/2010/main" val="3975417554"/>
+        <p14:creationId xmlns:p14="http://schemas.microsoft.com/office/powerpoint/2010/main" val="3307959019"/>
       </p:ext>
     </p:extLst>
   </p:cSld>

</xml_diff>